<commit_message>
docs: add postman placeholder slide
</commit_message>
<xml_diff>
--- a/docs/REST API Workshop.pptx
+++ b/docs/REST API Workshop.pptx
@@ -5,10 +5,10 @@
     <p:sldMasterId id="2147483648" r:id="rId4"/>
   </p:sldMasterIdLst>
   <p:notesMasterIdLst>
-    <p:notesMasterId r:id="rId16"/>
+    <p:notesMasterId r:id="rId17"/>
   </p:notesMasterIdLst>
   <p:handoutMasterIdLst>
-    <p:handoutMasterId r:id="rId17"/>
+    <p:handoutMasterId r:id="rId18"/>
   </p:handoutMasterIdLst>
   <p:sldIdLst>
     <p:sldId id="281" r:id="rId5"/>
@@ -22,6 +22,7 @@
     <p:sldId id="288" r:id="rId13"/>
     <p:sldId id="289" r:id="rId14"/>
     <p:sldId id="290" r:id="rId15"/>
+    <p:sldId id="292" r:id="rId16"/>
   </p:sldIdLst>
   <p:sldSz cx="10058400" cy="7772400"/>
   <p:notesSz cx="6858000" cy="9144000"/>
@@ -14917,6 +14918,273 @@
     <p:extLst>
       <p:ext uri="{BB962C8B-B14F-4D97-AF65-F5344CB8AC3E}">
         <p14:creationId xmlns:p14="http://schemas.microsoft.com/office/powerpoint/2010/main" val="4144966695"/>
+      </p:ext>
+    </p:extLst>
+  </p:cSld>
+  <p:clrMapOvr>
+    <a:masterClrMapping/>
+  </p:clrMapOvr>
+</p:sld>
+</file>
+
+<file path=ppt/slides/slide12.xml><?xml version="1.0" encoding="utf-8"?>
+<p:sld xmlns:a="http://schemas.openxmlformats.org/drawingml/2006/main" xmlns:r="http://schemas.openxmlformats.org/officeDocument/2006/relationships" xmlns:p="http://schemas.openxmlformats.org/presentationml/2006/main">
+  <p:cSld>
+    <p:bg>
+      <p:bgPr>
+        <a:solidFill>
+          <a:schemeClr val="bg1"/>
+        </a:solidFill>
+        <a:effectLst/>
+      </p:bgPr>
+    </p:bg>
+    <p:spTree>
+      <p:nvGrpSpPr>
+        <p:cNvPr id="1" name="">
+          <a:extLst>
+            <a:ext uri="{FF2B5EF4-FFF2-40B4-BE49-F238E27FC236}">
+              <a16:creationId xmlns:a16="http://schemas.microsoft.com/office/drawing/2014/main" id="{61F2E731-AED4-CD82-27CB-FDA9EB78F9AA}"/>
+            </a:ext>
+          </a:extLst>
+        </p:cNvPr>
+        <p:cNvGrpSpPr/>
+        <p:nvPr/>
+      </p:nvGrpSpPr>
+      <p:grpSpPr>
+        <a:xfrm>
+          <a:off x="0" y="0"/>
+          <a:ext cx="0" cy="0"/>
+          <a:chOff x="0" y="0"/>
+          <a:chExt cx="0" cy="0"/>
+        </a:xfrm>
+      </p:grpSpPr>
+      <p:sp>
+        <p:nvSpPr>
+          <p:cNvPr id="2" name="Title 1" hidden="1">
+            <a:extLst>
+              <a:ext uri="{FF2B5EF4-FFF2-40B4-BE49-F238E27FC236}">
+                <a16:creationId xmlns:a16="http://schemas.microsoft.com/office/drawing/2014/main" id="{22B52629-263F-2E6F-885B-F8CF97950FD6}"/>
+              </a:ext>
+            </a:extLst>
+          </p:cNvPr>
+          <p:cNvSpPr>
+            <a:spLocks noGrp="1"/>
+          </p:cNvSpPr>
+          <p:nvPr>
+            <p:ph type="title"/>
+          </p:nvPr>
+        </p:nvSpPr>
+        <p:spPr/>
+        <p:txBody>
+          <a:bodyPr/>
+          <a:lstStyle/>
+          <a:p>
+            <a:r>
+              <a:rPr lang="en-US" dirty="0"/>
+              <a:t>Cover Page</a:t>
+            </a:r>
+          </a:p>
+        </p:txBody>
+      </p:sp>
+      <p:sp>
+        <p:nvSpPr>
+          <p:cNvPr id="8" name="Title 1">
+            <a:extLst>
+              <a:ext uri="{FF2B5EF4-FFF2-40B4-BE49-F238E27FC236}">
+                <a16:creationId xmlns:a16="http://schemas.microsoft.com/office/drawing/2014/main" id="{40684A58-A206-6CD9-6C6D-8D3496F0594B}"/>
+              </a:ext>
+            </a:extLst>
+          </p:cNvPr>
+          <p:cNvSpPr txBox="1">
+            <a:spLocks/>
+          </p:cNvSpPr>
+          <p:nvPr/>
+        </p:nvSpPr>
+        <p:spPr>
+          <a:xfrm>
+            <a:off x="1161975" y="151635"/>
+            <a:ext cx="7804774" cy="719719"/>
+          </a:xfrm>
+          <a:prstGeom prst="rect">
+            <a:avLst/>
+          </a:prstGeom>
+        </p:spPr>
+        <p:txBody>
+          <a:bodyPr vert="horz" lIns="0" tIns="0" rIns="0" bIns="0" rtlCol="0" anchor="t">
+            <a:noAutofit/>
+          </a:bodyPr>
+          <a:lstStyle>
+            <a:lvl1pPr algn="ctr" defTabSz="754380" rtl="0" eaLnBrk="1" latinLnBrk="0" hangingPunct="1">
+              <a:lnSpc>
+                <a:spcPct val="90000"/>
+              </a:lnSpc>
+              <a:spcBef>
+                <a:spcPct val="0"/>
+              </a:spcBef>
+              <a:buNone/>
+              <a:defRPr sz="4000" kern="1200">
+                <a:solidFill>
+                  <a:schemeClr val="tx1"/>
+                </a:solidFill>
+                <a:latin typeface="+mj-lt"/>
+                <a:ea typeface="+mj-ea"/>
+                <a:cs typeface="+mj-cs"/>
+              </a:defRPr>
+            </a:lvl1pPr>
+          </a:lstStyle>
+          <a:p>
+            <a:pPr>
+              <a:lnSpc>
+                <a:spcPct val="75000"/>
+              </a:lnSpc>
+            </a:pPr>
+            <a:r>
+              <a:rPr lang="en-US" sz="6000" u="sng" dirty="0">
+                <a:ln w="41275">
+                  <a:noFill/>
+                </a:ln>
+                <a:solidFill>
+                  <a:schemeClr val="accent2"/>
+                </a:solidFill>
+                <a:ea typeface="Source Sans Pro Black"/>
+              </a:rPr>
+              <a:t>Postman</a:t>
+            </a:r>
+          </a:p>
+          <a:p>
+            <a:pPr>
+              <a:lnSpc>
+                <a:spcPct val="75000"/>
+              </a:lnSpc>
+            </a:pPr>
+            <a:r>
+              <a:rPr lang="en-US" sz="3200" dirty="0">
+                <a:ln w="41275">
+                  <a:noFill/>
+                </a:ln>
+                <a:solidFill>
+                  <a:schemeClr val="tx1">
+                    <a:lumMod val="76000"/>
+                    <a:lumOff val="24000"/>
+                  </a:schemeClr>
+                </a:solidFill>
+                <a:ea typeface="Source Sans Pro Black"/>
+              </a:rPr>
+              <a:t>Now you try</a:t>
+            </a:r>
+            <a:endParaRPr lang="en-US" sz="3200" u="sng" dirty="0">
+              <a:ln w="41275">
+                <a:noFill/>
+              </a:ln>
+              <a:solidFill>
+                <a:schemeClr val="tx1">
+                  <a:lumMod val="76000"/>
+                  <a:lumOff val="24000"/>
+                </a:schemeClr>
+              </a:solidFill>
+              <a:ea typeface="Source Sans Pro Black"/>
+            </a:endParaRPr>
+          </a:p>
+        </p:txBody>
+      </p:sp>
+      <p:sp>
+        <p:nvSpPr>
+          <p:cNvPr id="32" name="TextBox 31">
+            <a:extLst>
+              <a:ext uri="{FF2B5EF4-FFF2-40B4-BE49-F238E27FC236}">
+                <a16:creationId xmlns:a16="http://schemas.microsoft.com/office/drawing/2014/main" id="{837B7CAE-565E-9757-D11D-E7641A17D49F}"/>
+              </a:ext>
+            </a:extLst>
+          </p:cNvPr>
+          <p:cNvSpPr txBox="1"/>
+          <p:nvPr/>
+        </p:nvSpPr>
+        <p:spPr>
+          <a:xfrm>
+            <a:off x="2395248" y="1652683"/>
+            <a:ext cx="5257799" cy="1200329"/>
+          </a:xfrm>
+          <a:prstGeom prst="rect">
+            <a:avLst/>
+          </a:prstGeom>
+          <a:noFill/>
+        </p:spPr>
+        <p:txBody>
+          <a:bodyPr rot="0" spcFirstLastPara="0" vertOverflow="overflow" horzOverflow="overflow" vert="horz" wrap="square" lIns="91440" tIns="45720" rIns="91440" bIns="45720" numCol="1" spcCol="0" rtlCol="0" fromWordArt="0" anchor="t" anchorCtr="0" forceAA="0" compatLnSpc="1">
+            <a:prstTxWarp prst="textNoShape">
+              <a:avLst/>
+            </a:prstTxWarp>
+            <a:spAutoFit/>
+          </a:bodyPr>
+          <a:lstStyle/>
+          <a:p>
+            <a:pPr algn="ctr"/>
+            <a:br>
+              <a:rPr lang="en-GB" sz="3600" dirty="0">
+                <a:ea typeface="Source Sans Pro"/>
+              </a:rPr>
+            </a:br>
+            <a:endParaRPr lang="en-GB" sz="3600">
+              <a:solidFill>
+                <a:schemeClr val="bg2">
+                  <a:lumMod val="49000"/>
+                </a:schemeClr>
+              </a:solidFill>
+              <a:ea typeface="Source Sans Pro"/>
+            </a:endParaRPr>
+          </a:p>
+        </p:txBody>
+      </p:sp>
+      <p:cxnSp>
+        <p:nvCxnSpPr>
+          <p:cNvPr id="47" name="Straight Connector 46">
+            <a:extLst>
+              <a:ext uri="{FF2B5EF4-FFF2-40B4-BE49-F238E27FC236}">
+                <a16:creationId xmlns:a16="http://schemas.microsoft.com/office/drawing/2014/main" id="{C7CEA8FC-EDBD-40E8-1D42-70C38D68F2EC}"/>
+              </a:ext>
+              <a:ext uri="{C183D7F6-B498-43B3-948B-1728B52AA6E4}">
+                <adec:decorative xmlns:adec="http://schemas.microsoft.com/office/drawing/2017/decorative" val="1"/>
+              </a:ext>
+            </a:extLst>
+          </p:cNvPr>
+          <p:cNvCxnSpPr>
+            <a:cxnSpLocks/>
+          </p:cNvCxnSpPr>
+          <p:nvPr/>
+        </p:nvCxnSpPr>
+        <p:spPr>
+          <a:xfrm>
+            <a:off x="839615" y="1271285"/>
+            <a:ext cx="8677751" cy="0"/>
+          </a:xfrm>
+          <a:prstGeom prst="line">
+            <a:avLst/>
+          </a:prstGeom>
+          <a:ln w="25400">
+            <a:solidFill>
+              <a:schemeClr val="accent2"/>
+            </a:solidFill>
+          </a:ln>
+        </p:spPr>
+        <p:style>
+          <a:lnRef idx="1">
+            <a:schemeClr val="accent1"/>
+          </a:lnRef>
+          <a:fillRef idx="0">
+            <a:schemeClr val="accent1"/>
+          </a:fillRef>
+          <a:effectRef idx="0">
+            <a:schemeClr val="accent1"/>
+          </a:effectRef>
+          <a:fontRef idx="minor">
+            <a:schemeClr val="tx1"/>
+          </a:fontRef>
+        </p:style>
+      </p:cxnSp>
+    </p:spTree>
+    <p:extLst>
+      <p:ext uri="{BB962C8B-B14F-4D97-AF65-F5344CB8AC3E}">
+        <p14:creationId xmlns:p14="http://schemas.microsoft.com/office/powerpoint/2010/main" val="2273134353"/>
       </p:ext>
     </p:extLst>
   </p:cSld>
@@ -28009,26 +28277,6 @@
 </file>
 
 <file path=customXml/item1.xml><?xml version="1.0" encoding="utf-8"?>
-<p:properties xmlns:p="http://schemas.microsoft.com/office/2006/metadata/properties" xmlns:xsi="http://www.w3.org/2001/XMLSchema-instance" xmlns:pc="http://schemas.microsoft.com/office/infopath/2007/PartnerControls">
-  <documentManagement>
-    <_ip_UnifiedCompliancePolicyUIAction xmlns="http://schemas.microsoft.com/sharepoint/v3" xsi:nil="true"/>
-    <Image xmlns="71af3243-3dd4-4a8d-8c0d-dd76da1f02a5">
-      <Url xsi:nil="true"/>
-      <Description xsi:nil="true"/>
-    </Image>
-    <Status xmlns="71af3243-3dd4-4a8d-8c0d-dd76da1f02a5">Not started</Status>
-    <Background xmlns="71af3243-3dd4-4a8d-8c0d-dd76da1f02a5">false</Background>
-    <_ip_UnifiedCompliancePolicyProperties xmlns="http://schemas.microsoft.com/sharepoint/v3" xsi:nil="true"/>
-    <ImageTagsTaxHTField xmlns="71af3243-3dd4-4a8d-8c0d-dd76da1f02a5">
-      <Terms xmlns="http://schemas.microsoft.com/office/infopath/2007/PartnerControls"/>
-    </ImageTagsTaxHTField>
-    <TaxCatchAll xmlns="230e9df3-be65-4c73-a93b-d1236ebd677e" xsi:nil="true"/>
-    <MediaServiceKeyPoints xmlns="71af3243-3dd4-4a8d-8c0d-dd76da1f02a5" xsi:nil="true"/>
-  </documentManagement>
-</p:properties>
-</file>
-
-<file path=customXml/item2.xml><?xml version="1.0" encoding="utf-8"?>
 <ct:contentTypeSchema xmlns:ct="http://schemas.microsoft.com/office/2006/metadata/contentType" xmlns:ma="http://schemas.microsoft.com/office/2006/metadata/properties/metaAttributes" ct:_="" ma:_="" ma:contentTypeName="Document" ma:contentTypeID="0x01010079F111ED35F8CC479449609E8A0923A6" ma:contentTypeVersion="26" ma:contentTypeDescription="Create a new document." ma:contentTypeScope="" ma:versionID="ac37c1753acd5e330d2062ccec26ea66">
   <xsd:schema xmlns:xsd="http://www.w3.org/2001/XMLSchema" xmlns:xs="http://www.w3.org/2001/XMLSchema" xmlns:p="http://schemas.microsoft.com/office/2006/metadata/properties" xmlns:ns1="http://schemas.microsoft.com/sharepoint/v3" xmlns:ns2="71af3243-3dd4-4a8d-8c0d-dd76da1f02a5" xmlns:ns3="16c05727-aa75-4e4a-9b5f-8a80a1165891" xmlns:ns4="230e9df3-be65-4c73-a93b-d1236ebd677e" targetNamespace="http://schemas.microsoft.com/office/2006/metadata/properties" ma:root="true" ma:fieldsID="3b340c7101c92c5120abd06486f94548" ns1:_="" ns2:_="" ns3:_="" ns4:_="">
     <xsd:import namespace="http://schemas.microsoft.com/sharepoint/v3"/>
@@ -28328,6 +28576,26 @@
 </ct:contentTypeSchema>
 </file>
 
+<file path=customXml/item2.xml><?xml version="1.0" encoding="utf-8"?>
+<p:properties xmlns:p="http://schemas.microsoft.com/office/2006/metadata/properties" xmlns:xsi="http://www.w3.org/2001/XMLSchema-instance" xmlns:pc="http://schemas.microsoft.com/office/infopath/2007/PartnerControls">
+  <documentManagement>
+    <_ip_UnifiedCompliancePolicyUIAction xmlns="http://schemas.microsoft.com/sharepoint/v3" xsi:nil="true"/>
+    <Image xmlns="71af3243-3dd4-4a8d-8c0d-dd76da1f02a5">
+      <Url xsi:nil="true"/>
+      <Description xsi:nil="true"/>
+    </Image>
+    <Status xmlns="71af3243-3dd4-4a8d-8c0d-dd76da1f02a5">Not started</Status>
+    <Background xmlns="71af3243-3dd4-4a8d-8c0d-dd76da1f02a5">false</Background>
+    <_ip_UnifiedCompliancePolicyProperties xmlns="http://schemas.microsoft.com/sharepoint/v3" xsi:nil="true"/>
+    <ImageTagsTaxHTField xmlns="71af3243-3dd4-4a8d-8c0d-dd76da1f02a5">
+      <Terms xmlns="http://schemas.microsoft.com/office/infopath/2007/PartnerControls"/>
+    </ImageTagsTaxHTField>
+    <TaxCatchAll xmlns="230e9df3-be65-4c73-a93b-d1236ebd677e" xsi:nil="true"/>
+    <MediaServiceKeyPoints xmlns="71af3243-3dd4-4a8d-8c0d-dd76da1f02a5" xsi:nil="true"/>
+  </documentManagement>
+</p:properties>
+</file>
+
 <file path=customXml/item3.xml><?xml version="1.0" encoding="utf-8"?>
 <?mso-contentType ?>
 <FormTemplates xmlns="http://schemas.microsoft.com/sharepoint/v3/contenttype/forms">
@@ -28338,18 +28606,6 @@
 </file>
 
 <file path=customXml/itemProps1.xml><?xml version="1.0" encoding="utf-8"?>
-<ds:datastoreItem xmlns:ds="http://schemas.openxmlformats.org/officeDocument/2006/customXml" ds:itemID="{BA7C7500-373E-4155-9EAA-9FE9576B0BE6}">
-  <ds:schemaRefs>
-    <ds:schemaRef ds:uri="http://schemas.microsoft.com/office/2006/metadata/properties"/>
-    <ds:schemaRef ds:uri="http://schemas.microsoft.com/office/infopath/2007/PartnerControls"/>
-    <ds:schemaRef ds:uri="http://schemas.microsoft.com/sharepoint/v3"/>
-    <ds:schemaRef ds:uri="71af3243-3dd4-4a8d-8c0d-dd76da1f02a5"/>
-    <ds:schemaRef ds:uri="230e9df3-be65-4c73-a93b-d1236ebd677e"/>
-  </ds:schemaRefs>
-</ds:datastoreItem>
-</file>
-
-<file path=customXml/itemProps2.xml><?xml version="1.0" encoding="utf-8"?>
 <ds:datastoreItem xmlns:ds="http://schemas.openxmlformats.org/officeDocument/2006/customXml" ds:itemID="{5D948EC7-70A8-4BA0-9397-CCEC9EEE03CC}">
   <ds:schemaRefs>
     <ds:schemaRef ds:uri="http://schemas.microsoft.com/office/2006/metadata/contentType"/>
@@ -28370,6 +28626,18 @@
 </ds:datastoreItem>
 </file>
 
+<file path=customXml/itemProps2.xml><?xml version="1.0" encoding="utf-8"?>
+<ds:datastoreItem xmlns:ds="http://schemas.openxmlformats.org/officeDocument/2006/customXml" ds:itemID="{BA7C7500-373E-4155-9EAA-9FE9576B0BE6}">
+  <ds:schemaRefs>
+    <ds:schemaRef ds:uri="http://schemas.microsoft.com/office/2006/metadata/properties"/>
+    <ds:schemaRef ds:uri="http://schemas.microsoft.com/office/infopath/2007/PartnerControls"/>
+    <ds:schemaRef ds:uri="http://schemas.microsoft.com/sharepoint/v3"/>
+    <ds:schemaRef ds:uri="71af3243-3dd4-4a8d-8c0d-dd76da1f02a5"/>
+    <ds:schemaRef ds:uri="230e9df3-be65-4c73-a93b-d1236ebd677e"/>
+  </ds:schemaRefs>
+</ds:datastoreItem>
+</file>
+
 <file path=customXml/itemProps3.xml><?xml version="1.0" encoding="utf-8"?>
 <ds:datastoreItem xmlns:ds="http://schemas.openxmlformats.org/officeDocument/2006/customXml" ds:itemID="{C700B919-5B9C-4D06-B24A-7BB87EEF69EA}">
   <ds:schemaRefs>

</xml_diff>

<commit_message>
docs: add solution, ready check and robots to slides
</commit_message>
<xml_diff>
--- a/docs/REST API Workshop.pptx
+++ b/docs/REST API Workshop.pptx
@@ -5,10 +5,10 @@
     <p:sldMasterId id="2147483648" r:id="rId4"/>
   </p:sldMasterIdLst>
   <p:notesMasterIdLst>
-    <p:notesMasterId r:id="rId31"/>
+    <p:notesMasterId r:id="rId33"/>
   </p:notesMasterIdLst>
   <p:handoutMasterIdLst>
-    <p:handoutMasterId r:id="rId32"/>
+    <p:handoutMasterId r:id="rId34"/>
   </p:handoutMasterIdLst>
   <p:sldIdLst>
     <p:sldId id="281" r:id="rId5"/>
@@ -16,27 +16,29 @@
     <p:sldId id="283" r:id="rId7"/>
     <p:sldId id="284" r:id="rId8"/>
     <p:sldId id="296" r:id="rId9"/>
-    <p:sldId id="285" r:id="rId10"/>
-    <p:sldId id="286" r:id="rId11"/>
-    <p:sldId id="287" r:id="rId12"/>
-    <p:sldId id="291" r:id="rId13"/>
-    <p:sldId id="307" r:id="rId14"/>
-    <p:sldId id="308" r:id="rId15"/>
-    <p:sldId id="311" r:id="rId16"/>
-    <p:sldId id="290" r:id="rId17"/>
-    <p:sldId id="292" r:id="rId18"/>
-    <p:sldId id="304" r:id="rId19"/>
-    <p:sldId id="293" r:id="rId20"/>
-    <p:sldId id="294" r:id="rId21"/>
-    <p:sldId id="295" r:id="rId22"/>
-    <p:sldId id="297" r:id="rId23"/>
-    <p:sldId id="298" r:id="rId24"/>
-    <p:sldId id="299" r:id="rId25"/>
-    <p:sldId id="301" r:id="rId26"/>
-    <p:sldId id="302" r:id="rId27"/>
-    <p:sldId id="303" r:id="rId28"/>
-    <p:sldId id="305" r:id="rId29"/>
-    <p:sldId id="306" r:id="rId30"/>
+    <p:sldId id="312" r:id="rId10"/>
+    <p:sldId id="285" r:id="rId11"/>
+    <p:sldId id="286" r:id="rId12"/>
+    <p:sldId id="287" r:id="rId13"/>
+    <p:sldId id="291" r:id="rId14"/>
+    <p:sldId id="307" r:id="rId15"/>
+    <p:sldId id="308" r:id="rId16"/>
+    <p:sldId id="311" r:id="rId17"/>
+    <p:sldId id="290" r:id="rId18"/>
+    <p:sldId id="292" r:id="rId19"/>
+    <p:sldId id="304" r:id="rId20"/>
+    <p:sldId id="293" r:id="rId21"/>
+    <p:sldId id="294" r:id="rId22"/>
+    <p:sldId id="295" r:id="rId23"/>
+    <p:sldId id="297" r:id="rId24"/>
+    <p:sldId id="298" r:id="rId25"/>
+    <p:sldId id="299" r:id="rId26"/>
+    <p:sldId id="301" r:id="rId27"/>
+    <p:sldId id="302" r:id="rId28"/>
+    <p:sldId id="303" r:id="rId29"/>
+    <p:sldId id="305" r:id="rId30"/>
+    <p:sldId id="306" r:id="rId31"/>
+    <p:sldId id="313" r:id="rId32"/>
   </p:sldIdLst>
   <p:sldSz cx="10058400" cy="7772400"/>
   <p:notesSz cx="6858000" cy="9144000"/>
@@ -261,7 +263,7 @@
           <a:p>
             <a:fld id="{668871CB-7D37-4FAB-B9ED-4377A4D8FB20}" type="datetimeFigureOut">
               <a:rPr lang="en-US" smtClean="0"/>
-              <a:t>5/12/2026</a:t>
+              <a:t>5/14/2026</a:t>
             </a:fld>
             <a:endParaRPr lang="en-US" dirty="0"/>
           </a:p>
@@ -438,7 +440,7 @@
           <a:p>
             <a:fld id="{443EEF79-99CC-4F81-B4D6-D8238D76DBFC}" type="datetimeFigureOut">
               <a:rPr lang="en-US" smtClean="0"/>
-              <a:t>5/12/2026</a:t>
+              <a:t>5/14/2026</a:t>
             </a:fld>
             <a:endParaRPr lang="en-US" dirty="0"/>
           </a:p>
@@ -879,7 +881,7 @@
           <a:p>
             <a:fld id="{B32EBECA-3212-4A5B-B9AF-C03EDE72AD91}" type="datetimeFigureOut">
               <a:rPr lang="en-US" smtClean="0"/>
-              <a:t>5/12/2026</a:t>
+              <a:t>5/14/2026</a:t>
             </a:fld>
             <a:endParaRPr lang="en-US" dirty="0"/>
           </a:p>
@@ -1064,7 +1066,7 @@
           <a:p>
             <a:fld id="{B32EBECA-3212-4A5B-B9AF-C03EDE72AD91}" type="datetimeFigureOut">
               <a:rPr lang="en-US" smtClean="0"/>
-              <a:t>5/12/2026</a:t>
+              <a:t>5/14/2026</a:t>
             </a:fld>
             <a:endParaRPr lang="en-US" dirty="0"/>
           </a:p>
@@ -1305,7 +1307,7 @@
           <a:p>
             <a:fld id="{B32EBECA-3212-4A5B-B9AF-C03EDE72AD91}" type="datetimeFigureOut">
               <a:rPr lang="en-US" smtClean="0"/>
-              <a:t>5/12/2026</a:t>
+              <a:t>5/14/2026</a:t>
             </a:fld>
             <a:endParaRPr lang="en-US" dirty="0"/>
           </a:p>
@@ -14018,6 +14020,584 @@
         <p:cNvPr id="1" name="">
           <a:extLst>
             <a:ext uri="{FF2B5EF4-FFF2-40B4-BE49-F238E27FC236}">
+              <a16:creationId xmlns:a16="http://schemas.microsoft.com/office/drawing/2014/main" id="{3620E0B4-EF70-230E-FE50-7B9FF95E94EE}"/>
+            </a:ext>
+          </a:extLst>
+        </p:cNvPr>
+        <p:cNvGrpSpPr/>
+        <p:nvPr/>
+      </p:nvGrpSpPr>
+      <p:grpSpPr>
+        <a:xfrm>
+          <a:off x="0" y="0"/>
+          <a:ext cx="0" cy="0"/>
+          <a:chOff x="0" y="0"/>
+          <a:chExt cx="0" cy="0"/>
+        </a:xfrm>
+      </p:grpSpPr>
+      <p:sp>
+        <p:nvSpPr>
+          <p:cNvPr id="2" name="Title 1" hidden="1">
+            <a:extLst>
+              <a:ext uri="{FF2B5EF4-FFF2-40B4-BE49-F238E27FC236}">
+                <a16:creationId xmlns:a16="http://schemas.microsoft.com/office/drawing/2014/main" id="{582F56C0-4B4F-4445-7D2D-69CC65646A61}"/>
+              </a:ext>
+            </a:extLst>
+          </p:cNvPr>
+          <p:cNvSpPr>
+            <a:spLocks noGrp="1"/>
+          </p:cNvSpPr>
+          <p:nvPr>
+            <p:ph type="title"/>
+          </p:nvPr>
+        </p:nvSpPr>
+        <p:spPr/>
+        <p:txBody>
+          <a:bodyPr/>
+          <a:lstStyle/>
+          <a:p>
+            <a:r>
+              <a:rPr lang="en-US" dirty="0"/>
+              <a:t>Cover Page</a:t>
+            </a:r>
+          </a:p>
+        </p:txBody>
+      </p:sp>
+      <p:sp>
+        <p:nvSpPr>
+          <p:cNvPr id="8" name="Title 1">
+            <a:extLst>
+              <a:ext uri="{FF2B5EF4-FFF2-40B4-BE49-F238E27FC236}">
+                <a16:creationId xmlns:a16="http://schemas.microsoft.com/office/drawing/2014/main" id="{CC281F5C-A967-F0BE-F681-D41DC883BFF6}"/>
+              </a:ext>
+            </a:extLst>
+          </p:cNvPr>
+          <p:cNvSpPr txBox="1">
+            <a:spLocks/>
+          </p:cNvSpPr>
+          <p:nvPr/>
+        </p:nvSpPr>
+        <p:spPr>
+          <a:xfrm>
+            <a:off x="2403752" y="399811"/>
+            <a:ext cx="5253486" cy="719719"/>
+          </a:xfrm>
+          <a:prstGeom prst="rect">
+            <a:avLst/>
+          </a:prstGeom>
+        </p:spPr>
+        <p:txBody>
+          <a:bodyPr vert="horz" lIns="0" tIns="0" rIns="0" bIns="0" rtlCol="0" anchor="t">
+            <a:noAutofit/>
+          </a:bodyPr>
+          <a:lstStyle>
+            <a:lvl1pPr algn="ctr" defTabSz="754380" rtl="0" eaLnBrk="1" latinLnBrk="0" hangingPunct="1">
+              <a:lnSpc>
+                <a:spcPct val="90000"/>
+              </a:lnSpc>
+              <a:spcBef>
+                <a:spcPct val="0"/>
+              </a:spcBef>
+              <a:buNone/>
+              <a:defRPr sz="4000" kern="1200">
+                <a:solidFill>
+                  <a:schemeClr val="tx1"/>
+                </a:solidFill>
+                <a:latin typeface="+mj-lt"/>
+                <a:ea typeface="+mj-ea"/>
+                <a:cs typeface="+mj-cs"/>
+              </a:defRPr>
+            </a:lvl1pPr>
+          </a:lstStyle>
+          <a:p>
+            <a:pPr>
+              <a:lnSpc>
+                <a:spcPct val="75000"/>
+              </a:lnSpc>
+            </a:pPr>
+            <a:r>
+              <a:rPr lang="en-US" sz="6000" u="sng" dirty="0" err="1">
+                <a:ln w="41275">
+                  <a:noFill/>
+                </a:ln>
+                <a:solidFill>
+                  <a:schemeClr val="accent2"/>
+                </a:solidFill>
+                <a:ea typeface="Source Sans Pro Black"/>
+              </a:rPr>
+              <a:t>Gitflow</a:t>
+            </a:r>
+            <a:endParaRPr lang="en-US" u="sng" dirty="0" err="1">
+              <a:solidFill>
+                <a:schemeClr val="accent2"/>
+              </a:solidFill>
+            </a:endParaRPr>
+          </a:p>
+          <a:p>
+            <a:pPr>
+              <a:lnSpc>
+                <a:spcPct val="75000"/>
+              </a:lnSpc>
+            </a:pPr>
+            <a:r>
+              <a:rPr lang="en-US" sz="3200">
+                <a:ln w="41275">
+                  <a:noFill/>
+                </a:ln>
+                <a:solidFill>
+                  <a:schemeClr val="tx1">
+                    <a:lumMod val="76000"/>
+                    <a:lumOff val="24000"/>
+                  </a:schemeClr>
+                </a:solidFill>
+                <a:ea typeface="Source Sans Pro Black"/>
+              </a:rPr>
+              <a:t>Git Workflows</a:t>
+            </a:r>
+            <a:endParaRPr lang="en-US" sz="3200" u="sng" dirty="0">
+              <a:ln w="41275">
+                <a:noFill/>
+              </a:ln>
+              <a:solidFill>
+                <a:schemeClr val="tx1">
+                  <a:lumMod val="76000"/>
+                  <a:lumOff val="24000"/>
+                </a:schemeClr>
+              </a:solidFill>
+              <a:ea typeface="Source Sans Pro Black"/>
+            </a:endParaRPr>
+          </a:p>
+        </p:txBody>
+      </p:sp>
+      <p:sp>
+        <p:nvSpPr>
+          <p:cNvPr id="32" name="TextBox 31">
+            <a:extLst>
+              <a:ext uri="{FF2B5EF4-FFF2-40B4-BE49-F238E27FC236}">
+                <a16:creationId xmlns:a16="http://schemas.microsoft.com/office/drawing/2014/main" id="{B5712A2E-1781-225E-238D-5E6E3E3CEA5B}"/>
+              </a:ext>
+            </a:extLst>
+          </p:cNvPr>
+          <p:cNvSpPr txBox="1"/>
+          <p:nvPr/>
+        </p:nvSpPr>
+        <p:spPr>
+          <a:xfrm>
+            <a:off x="2395248" y="1652683"/>
+            <a:ext cx="5257799" cy="1200329"/>
+          </a:xfrm>
+          <a:prstGeom prst="rect">
+            <a:avLst/>
+          </a:prstGeom>
+          <a:noFill/>
+        </p:spPr>
+        <p:txBody>
+          <a:bodyPr rot="0" spcFirstLastPara="0" vertOverflow="overflow" horzOverflow="overflow" vert="horz" wrap="square" lIns="91440" tIns="45720" rIns="91440" bIns="45720" numCol="1" spcCol="0" rtlCol="0" fromWordArt="0" anchor="t" anchorCtr="0" forceAA="0" compatLnSpc="1">
+            <a:prstTxWarp prst="textNoShape">
+              <a:avLst/>
+            </a:prstTxWarp>
+            <a:spAutoFit/>
+          </a:bodyPr>
+          <a:lstStyle/>
+          <a:p>
+            <a:pPr algn="ctr"/>
+            <a:br>
+              <a:rPr lang="en-GB" sz="3600" dirty="0">
+                <a:ea typeface="Source Sans Pro"/>
+              </a:rPr>
+            </a:br>
+            <a:endParaRPr lang="en-GB" sz="3600">
+              <a:solidFill>
+                <a:schemeClr val="bg2">
+                  <a:lumMod val="49000"/>
+                </a:schemeClr>
+              </a:solidFill>
+              <a:ea typeface="Source Sans Pro"/>
+            </a:endParaRPr>
+          </a:p>
+        </p:txBody>
+      </p:sp>
+      <p:cxnSp>
+        <p:nvCxnSpPr>
+          <p:cNvPr id="47" name="Straight Connector 46">
+            <a:extLst>
+              <a:ext uri="{FF2B5EF4-FFF2-40B4-BE49-F238E27FC236}">
+                <a16:creationId xmlns:a16="http://schemas.microsoft.com/office/drawing/2014/main" id="{17CE5083-F6E9-18C8-284B-F1C4AF5FA3D9}"/>
+              </a:ext>
+              <a:ext uri="{C183D7F6-B498-43B3-948B-1728B52AA6E4}">
+                <adec:decorative xmlns:adec="http://schemas.microsoft.com/office/drawing/2017/decorative" val="1"/>
+              </a:ext>
+            </a:extLst>
+          </p:cNvPr>
+          <p:cNvCxnSpPr>
+            <a:cxnSpLocks/>
+          </p:cNvCxnSpPr>
+          <p:nvPr/>
+        </p:nvCxnSpPr>
+        <p:spPr>
+          <a:xfrm>
+            <a:off x="929926" y="1880443"/>
+            <a:ext cx="8677751" cy="0"/>
+          </a:xfrm>
+          <a:prstGeom prst="line">
+            <a:avLst/>
+          </a:prstGeom>
+          <a:ln w="25400">
+            <a:solidFill>
+              <a:schemeClr val="accent2"/>
+            </a:solidFill>
+          </a:ln>
+        </p:spPr>
+        <p:style>
+          <a:lnRef idx="1">
+            <a:schemeClr val="accent1"/>
+          </a:lnRef>
+          <a:fillRef idx="0">
+            <a:schemeClr val="accent1"/>
+          </a:fillRef>
+          <a:effectRef idx="0">
+            <a:schemeClr val="accent1"/>
+          </a:effectRef>
+          <a:fontRef idx="minor">
+            <a:schemeClr val="tx1"/>
+          </a:fontRef>
+        </p:style>
+      </p:cxnSp>
+      <p:pic>
+        <p:nvPicPr>
+          <p:cNvPr id="5" name="Graphic 4" descr="Hotfix branch within git workflow">
+            <a:extLst>
+              <a:ext uri="{FF2B5EF4-FFF2-40B4-BE49-F238E27FC236}">
+                <a16:creationId xmlns:a16="http://schemas.microsoft.com/office/drawing/2014/main" id="{23673354-41CF-DB5D-738E-24739AB056FB}"/>
+              </a:ext>
+            </a:extLst>
+          </p:cNvPr>
+          <p:cNvPicPr>
+            <a:picLocks noChangeAspect="1"/>
+          </p:cNvPicPr>
+          <p:nvPr/>
+        </p:nvPicPr>
+        <p:blipFill>
+          <a:blip>
+            <a:extLst>
+              <a:ext uri="{96DAC541-7B7A-43D3-8B79-37D633B846F1}">
+                <asvg:svgBlip xmlns:asvg="http://schemas.microsoft.com/office/drawing/2016/SVG/main" r:embed="rId2"/>
+              </a:ext>
+            </a:extLst>
+          </a:blip>
+          <a:stretch>
+            <a:fillRect/>
+          </a:stretch>
+        </p:blipFill>
+        <p:spPr>
+          <a:xfrm>
+            <a:off x="2875578" y="2052123"/>
+            <a:ext cx="6808252" cy="4864661"/>
+          </a:xfrm>
+          <a:prstGeom prst="rect">
+            <a:avLst/>
+          </a:prstGeom>
+        </p:spPr>
+      </p:pic>
+      <p:pic>
+        <p:nvPicPr>
+          <p:cNvPr id="3" name="Picture 2" descr="A cartoon character with a computer&#10;&#10;AI-generated content may be incorrect.">
+            <a:extLst>
+              <a:ext uri="{FF2B5EF4-FFF2-40B4-BE49-F238E27FC236}">
+                <a16:creationId xmlns:a16="http://schemas.microsoft.com/office/drawing/2014/main" id="{21BCB5C4-433E-CBE4-7FE7-7773102DA8C7}"/>
+              </a:ext>
+            </a:extLst>
+          </p:cNvPr>
+          <p:cNvPicPr>
+            <a:picLocks noChangeAspect="1"/>
+          </p:cNvPicPr>
+          <p:nvPr/>
+        </p:nvPicPr>
+        <p:blipFill>
+          <a:blip r:embed="rId3"/>
+          <a:stretch>
+            <a:fillRect/>
+          </a:stretch>
+        </p:blipFill>
+        <p:spPr>
+          <a:xfrm rot="360000">
+            <a:off x="2075205" y="59612"/>
+            <a:ext cx="1595041" cy="1509430"/>
+          </a:xfrm>
+          <a:prstGeom prst="rect">
+            <a:avLst/>
+          </a:prstGeom>
+          <a:ln>
+            <a:noFill/>
+          </a:ln>
+          <a:effectLst>
+            <a:softEdge rad="112500"/>
+          </a:effectLst>
+        </p:spPr>
+      </p:pic>
+      <p:sp>
+        <p:nvSpPr>
+          <p:cNvPr id="4" name="TextBox 3">
+            <a:extLst>
+              <a:ext uri="{FF2B5EF4-FFF2-40B4-BE49-F238E27FC236}">
+                <a16:creationId xmlns:a16="http://schemas.microsoft.com/office/drawing/2014/main" id="{29EA55F1-5084-6A30-566B-F1583FF7DA2E}"/>
+              </a:ext>
+            </a:extLst>
+          </p:cNvPr>
+          <p:cNvSpPr txBox="1"/>
+          <p:nvPr/>
+        </p:nvSpPr>
+        <p:spPr>
+          <a:xfrm>
+            <a:off x="130679" y="3232340"/>
+            <a:ext cx="2743199" cy="1938992"/>
+          </a:xfrm>
+          <a:prstGeom prst="rect">
+            <a:avLst/>
+          </a:prstGeom>
+          <a:noFill/>
+        </p:spPr>
+        <p:txBody>
+          <a:bodyPr rot="0" spcFirstLastPara="0" vertOverflow="overflow" horzOverflow="overflow" vert="horz" wrap="square" lIns="91440" tIns="45720" rIns="91440" bIns="45720" numCol="1" spcCol="0" rtlCol="0" fromWordArt="0" anchor="t" anchorCtr="0" forceAA="0" compatLnSpc="1">
+            <a:prstTxWarp prst="textNoShape">
+              <a:avLst/>
+            </a:prstTxWarp>
+            <a:spAutoFit/>
+          </a:bodyPr>
+          <a:lstStyle/>
+          <a:p>
+            <a:r>
+              <a:rPr lang="en-GB" sz="2000" b="1">
+                <a:ea typeface="Source Sans Pro"/>
+              </a:rPr>
+              <a:t>Examples of branches:</a:t>
+            </a:r>
+            <a:endParaRPr lang="en-US" b="1"/>
+          </a:p>
+          <a:p>
+            <a:pPr marL="342900" indent="-342900">
+              <a:buFont typeface="Wingdings"/>
+              <a:buChar char="ü"/>
+            </a:pPr>
+            <a:r>
+              <a:rPr lang="en-GB" sz="2000" b="1">
+                <a:ea typeface="Source Sans Pro"/>
+              </a:rPr>
+              <a:t>main</a:t>
+            </a:r>
+            <a:endParaRPr lang="en-GB" sz="2000" dirty="0">
+              <a:ea typeface="Source Sans Pro"/>
+            </a:endParaRPr>
+          </a:p>
+          <a:p>
+            <a:pPr marL="342900" indent="-342900">
+              <a:buFont typeface="Wingdings"/>
+              <a:buChar char="ü"/>
+            </a:pPr>
+            <a:r>
+              <a:rPr lang="en-GB" sz="2000" b="1">
+                <a:ea typeface="Source Sans Pro"/>
+              </a:rPr>
+              <a:t>develop</a:t>
+            </a:r>
+            <a:endParaRPr lang="en-GB" sz="2000" dirty="0">
+              <a:ea typeface="Source Sans Pro"/>
+            </a:endParaRPr>
+          </a:p>
+          <a:p>
+            <a:pPr marL="342900" indent="-342900">
+              <a:buFont typeface="Wingdings"/>
+              <a:buChar char="ü"/>
+            </a:pPr>
+            <a:r>
+              <a:rPr lang="en-GB" sz="2000" b="1">
+                <a:ea typeface="Source Sans Pro"/>
+              </a:rPr>
+              <a:t>hotfix</a:t>
+            </a:r>
+            <a:r>
+              <a:rPr lang="en-GB" sz="2000">
+                <a:ea typeface="Source Sans Pro"/>
+              </a:rPr>
+              <a:t>/page-crash</a:t>
+            </a:r>
+          </a:p>
+          <a:p>
+            <a:pPr marL="342900" indent="-342900">
+              <a:buFont typeface="Wingdings"/>
+              <a:buChar char="ü"/>
+            </a:pPr>
+            <a:r>
+              <a:rPr lang="en-GB" sz="2000" b="1">
+                <a:ea typeface="Source Sans Pro"/>
+              </a:rPr>
+              <a:t>release</a:t>
+            </a:r>
+            <a:r>
+              <a:rPr lang="en-GB" sz="2000">
+                <a:ea typeface="Source Sans Pro"/>
+              </a:rPr>
+              <a:t>/1.0.0</a:t>
+            </a:r>
+          </a:p>
+          <a:p>
+            <a:pPr marL="342900" indent="-342900">
+              <a:buFont typeface="Wingdings"/>
+              <a:buChar char="ü"/>
+            </a:pPr>
+            <a:r>
+              <a:rPr lang="en-GB" sz="2000" b="1" dirty="0">
+                <a:ea typeface="Source Sans Pro"/>
+              </a:rPr>
+              <a:t>feature</a:t>
+            </a:r>
+            <a:r>
+              <a:rPr lang="en-GB" sz="2000" dirty="0">
+                <a:ea typeface="Source Sans Pro"/>
+              </a:rPr>
+              <a:t>/</a:t>
+            </a:r>
+            <a:r>
+              <a:rPr lang="en-GB" sz="2000" dirty="0" err="1">
+                <a:ea typeface="Source Sans Pro"/>
+              </a:rPr>
+              <a:t>todo</a:t>
+            </a:r>
+            <a:r>
+              <a:rPr lang="en-GB" sz="2000" dirty="0">
+                <a:ea typeface="Source Sans Pro"/>
+              </a:rPr>
+              <a:t>-page</a:t>
+            </a:r>
+          </a:p>
+        </p:txBody>
+      </p:sp>
+      <p:sp>
+        <p:nvSpPr>
+          <p:cNvPr id="6" name="TextBox 5">
+            <a:extLst>
+              <a:ext uri="{FF2B5EF4-FFF2-40B4-BE49-F238E27FC236}">
+                <a16:creationId xmlns:a16="http://schemas.microsoft.com/office/drawing/2014/main" id="{E3B2EB25-E3AE-77E3-8923-7FACD0D1D8FA}"/>
+              </a:ext>
+            </a:extLst>
+          </p:cNvPr>
+          <p:cNvSpPr txBox="1"/>
+          <p:nvPr/>
+        </p:nvSpPr>
+        <p:spPr>
+          <a:xfrm>
+            <a:off x="638421" y="7001411"/>
+            <a:ext cx="8791979" cy="1222642"/>
+          </a:xfrm>
+          <a:prstGeom prst="rect">
+            <a:avLst/>
+          </a:prstGeom>
+          <a:noFill/>
+        </p:spPr>
+        <p:txBody>
+          <a:bodyPr rot="0" spcFirstLastPara="0" vertOverflow="overflow" horzOverflow="overflow" vert="horz" wrap="square" lIns="91440" tIns="45720" rIns="91440" bIns="45720" numCol="1" spcCol="0" rtlCol="0" fromWordArt="0" anchor="t" anchorCtr="0" forceAA="0" compatLnSpc="1">
+            <a:prstTxWarp prst="textNoShape">
+              <a:avLst/>
+            </a:prstTxWarp>
+            <a:spAutoFit/>
+          </a:bodyPr>
+          <a:lstStyle/>
+          <a:p>
+            <a:pPr rtl="0">
+              <a:lnSpc>
+                <a:spcPts val="2025"/>
+              </a:lnSpc>
+            </a:pPr>
+            <a:r>
+              <a:rPr lang="en-GB" sz="2000" baseline="0">
+                <a:latin typeface="Source Sans Pro"/>
+                <a:ea typeface="Segoe UI"/>
+                <a:cs typeface="Segoe UI"/>
+              </a:rPr>
+              <a:t>Document reference:</a:t>
+            </a:r>
+            <a:r>
+              <a:rPr lang="en-GB" sz="2000">
+                <a:latin typeface="Source Sans Pro"/>
+                <a:ea typeface="Segoe UI"/>
+                <a:cs typeface="Segoe UI"/>
+              </a:rPr>
+              <a:t>​</a:t>
+            </a:r>
+            <a:br>
+              <a:rPr lang="en-GB" sz="2000">
+                <a:latin typeface="Source Sans Pro"/>
+                <a:ea typeface="Segoe UI"/>
+                <a:cs typeface="Segoe UI"/>
+              </a:rPr>
+            </a:br>
+            <a:r>
+              <a:rPr lang="en-GB" sz="2000" u="sng" strike="noStrike" baseline="0">
+                <a:solidFill>
+                  <a:srgbClr val="5F5F5F"/>
+                </a:solidFill>
+                <a:latin typeface="Source Sans Pro"/>
+                <a:ea typeface="Segoe UI"/>
+                <a:cs typeface="Segoe UI"/>
+                <a:hlinkClick r:id="rId4"/>
+              </a:rPr>
+              <a:t>https://www.atlassian.com/git/tutorials/comparing-workflows/gitflow-workflow</a:t>
+            </a:r>
+            <a:r>
+              <a:rPr lang="en-GB" sz="2000">
+                <a:latin typeface="Source Sans Pro"/>
+                <a:ea typeface="Segoe UI"/>
+                <a:cs typeface="Segoe UI"/>
+              </a:rPr>
+              <a:t>​</a:t>
+            </a:r>
+          </a:p>
+          <a:p>
+            <a:pPr marL="342900" lvl="0" indent="-342900" rtl="0">
+              <a:buFont typeface="Wingdings,Sans-Serif"/>
+              <a:buChar char="ü"/>
+            </a:pPr>
+            <a:endParaRPr lang="en-GB">
+              <a:latin typeface="Arial"/>
+              <a:ea typeface="Arial"/>
+              <a:cs typeface="Arial"/>
+            </a:endParaRPr>
+          </a:p>
+          <a:p>
+            <a:pPr algn="ctr"/>
+            <a:endParaRPr lang="en-GB"/>
+          </a:p>
+        </p:txBody>
+      </p:sp>
+    </p:spTree>
+    <p:extLst>
+      <p:ext uri="{BB962C8B-B14F-4D97-AF65-F5344CB8AC3E}">
+        <p14:creationId xmlns:p14="http://schemas.microsoft.com/office/powerpoint/2010/main" val="1120510944"/>
+      </p:ext>
+    </p:extLst>
+  </p:cSld>
+  <p:clrMapOvr>
+    <a:masterClrMapping/>
+  </p:clrMapOvr>
+</p:sld>
+</file>
+
+<file path=ppt/slides/slide11.xml><?xml version="1.0" encoding="utf-8"?>
+<p:sld xmlns:a="http://schemas.openxmlformats.org/drawingml/2006/main" xmlns:r="http://schemas.openxmlformats.org/officeDocument/2006/relationships" xmlns:p="http://schemas.openxmlformats.org/presentationml/2006/main">
+  <p:cSld>
+    <p:bg>
+      <p:bgPr>
+        <a:solidFill>
+          <a:schemeClr val="bg1"/>
+        </a:solidFill>
+        <a:effectLst/>
+      </p:bgPr>
+    </p:bg>
+    <p:spTree>
+      <p:nvGrpSpPr>
+        <p:cNvPr id="1" name="">
+          <a:extLst>
+            <a:ext uri="{FF2B5EF4-FFF2-40B4-BE49-F238E27FC236}">
               <a16:creationId xmlns:a16="http://schemas.microsoft.com/office/drawing/2014/main" id="{3D95C0EA-D49D-FC99-58BE-60AF032825ED}"/>
             </a:ext>
           </a:extLst>
@@ -14950,7 +15530,7 @@
 </p:sld>
 </file>
 
-<file path=ppt/slides/slide11.xml><?xml version="1.0" encoding="utf-8"?>
+<file path=ppt/slides/slide12.xml><?xml version="1.0" encoding="utf-8"?>
 <p:sld xmlns:a="http://schemas.openxmlformats.org/drawingml/2006/main" xmlns:r="http://schemas.openxmlformats.org/officeDocument/2006/relationships" xmlns:p="http://schemas.openxmlformats.org/presentationml/2006/main">
   <p:cSld>
     <p:bg>
@@ -16011,7 +16591,7 @@
 </p:sld>
 </file>
 
-<file path=ppt/slides/slide12.xml><?xml version="1.0" encoding="utf-8"?>
+<file path=ppt/slides/slide13.xml><?xml version="1.0" encoding="utf-8"?>
 <p:sld xmlns:a="http://schemas.openxmlformats.org/drawingml/2006/main" xmlns:r="http://schemas.openxmlformats.org/officeDocument/2006/relationships" xmlns:p="http://schemas.openxmlformats.org/presentationml/2006/main">
   <p:cSld>
     <p:bg>
@@ -17443,7 +18023,7 @@
 </p:sld>
 </file>
 
-<file path=ppt/slides/slide13.xml><?xml version="1.0" encoding="utf-8"?>
+<file path=ppt/slides/slide14.xml><?xml version="1.0" encoding="utf-8"?>
 <p:sld xmlns:a="http://schemas.openxmlformats.org/drawingml/2006/main" xmlns:r="http://schemas.openxmlformats.org/officeDocument/2006/relationships" xmlns:p="http://schemas.openxmlformats.org/presentationml/2006/main">
   <p:cSld>
     <p:bg>
@@ -17775,7 +18355,7 @@
 </p:sld>
 </file>
 
-<file path=ppt/slides/slide14.xml><?xml version="1.0" encoding="utf-8"?>
+<file path=ppt/slides/slide15.xml><?xml version="1.0" encoding="utf-8"?>
 <p:sld xmlns:a="http://schemas.openxmlformats.org/drawingml/2006/main" xmlns:r="http://schemas.openxmlformats.org/officeDocument/2006/relationships" xmlns:p="http://schemas.openxmlformats.org/presentationml/2006/main">
   <p:cSld>
     <p:bg>
@@ -18072,7 +18652,7 @@
 </p:sld>
 </file>
 
-<file path=ppt/slides/slide15.xml><?xml version="1.0" encoding="utf-8"?>
+<file path=ppt/slides/slide16.xml><?xml version="1.0" encoding="utf-8"?>
 <p:sld xmlns:a="http://schemas.openxmlformats.org/drawingml/2006/main" xmlns:r="http://schemas.openxmlformats.org/officeDocument/2006/relationships" xmlns:p="http://schemas.openxmlformats.org/presentationml/2006/main">
   <p:cSld>
     <p:bg>
@@ -18334,7 +18914,7 @@
 </p:sld>
 </file>
 
-<file path=ppt/slides/slide16.xml><?xml version="1.0" encoding="utf-8"?>
+<file path=ppt/slides/slide17.xml><?xml version="1.0" encoding="utf-8"?>
 <p:sld xmlns:a="http://schemas.openxmlformats.org/drawingml/2006/main" xmlns:r="http://schemas.openxmlformats.org/officeDocument/2006/relationships" xmlns:p="http://schemas.openxmlformats.org/presentationml/2006/main">
   <p:cSld>
     <p:bg>
@@ -18771,6 +19351,36 @@
           </a:p>
         </p:txBody>
       </p:sp>
+      <p:pic>
+        <p:nvPicPr>
+          <p:cNvPr id="5" name="Picture 4">
+            <a:extLst>
+              <a:ext uri="{FF2B5EF4-FFF2-40B4-BE49-F238E27FC236}">
+                <a16:creationId xmlns:a16="http://schemas.microsoft.com/office/drawing/2014/main" id="{D9F77BC0-3779-F3B8-6EB8-29BBE1DAA6A2}"/>
+              </a:ext>
+            </a:extLst>
+          </p:cNvPr>
+          <p:cNvPicPr>
+            <a:picLocks noChangeAspect="1"/>
+          </p:cNvPicPr>
+          <p:nvPr/>
+        </p:nvPicPr>
+        <p:blipFill>
+          <a:blip r:embed="rId6"/>
+          <a:stretch>
+            <a:fillRect/>
+          </a:stretch>
+        </p:blipFill>
+        <p:spPr>
+          <a:xfrm>
+            <a:off x="8733595" y="153454"/>
+            <a:ext cx="904996" cy="1117831"/>
+          </a:xfrm>
+          <a:prstGeom prst="rect">
+            <a:avLst/>
+          </a:prstGeom>
+        </p:spPr>
+      </p:pic>
     </p:spTree>
     <p:extLst>
       <p:ext uri="{BB962C8B-B14F-4D97-AF65-F5344CB8AC3E}">
@@ -18784,7 +19394,7 @@
 </p:sld>
 </file>
 
-<file path=ppt/slides/slide17.xml><?xml version="1.0" encoding="utf-8"?>
+<file path=ppt/slides/slide18.xml><?xml version="1.0" encoding="utf-8"?>
 <p:sld xmlns:a="http://schemas.openxmlformats.org/drawingml/2006/main" xmlns:r="http://schemas.openxmlformats.org/officeDocument/2006/relationships" xmlns:p="http://schemas.openxmlformats.org/presentationml/2006/main">
   <p:cSld>
     <p:bg>
@@ -19074,6 +19684,36 @@
           </a:prstGeom>
         </p:spPr>
       </p:pic>
+      <p:pic>
+        <p:nvPicPr>
+          <p:cNvPr id="3" name="Picture 2">
+            <a:extLst>
+              <a:ext uri="{FF2B5EF4-FFF2-40B4-BE49-F238E27FC236}">
+                <a16:creationId xmlns:a16="http://schemas.microsoft.com/office/drawing/2014/main" id="{6BAD4609-7AB0-14A5-EF85-9DF221D985A3}"/>
+              </a:ext>
+            </a:extLst>
+          </p:cNvPr>
+          <p:cNvPicPr>
+            <a:picLocks noChangeAspect="1"/>
+          </p:cNvPicPr>
+          <p:nvPr/>
+        </p:nvPicPr>
+        <p:blipFill>
+          <a:blip r:embed="rId3"/>
+          <a:stretch>
+            <a:fillRect/>
+          </a:stretch>
+        </p:blipFill>
+        <p:spPr>
+          <a:xfrm>
+            <a:off x="6557892" y="73667"/>
+            <a:ext cx="904996" cy="1117831"/>
+          </a:xfrm>
+          <a:prstGeom prst="rect">
+            <a:avLst/>
+          </a:prstGeom>
+        </p:spPr>
+      </p:pic>
     </p:spTree>
     <p:extLst>
       <p:ext uri="{BB962C8B-B14F-4D97-AF65-F5344CB8AC3E}">
@@ -19087,7 +19727,7 @@
 </p:sld>
 </file>
 
-<file path=ppt/slides/slide18.xml><?xml version="1.0" encoding="utf-8"?>
+<file path=ppt/slides/slide19.xml><?xml version="1.0" encoding="utf-8"?>
 <p:sld xmlns:a="http://schemas.openxmlformats.org/drawingml/2006/main" xmlns:r="http://schemas.openxmlformats.org/officeDocument/2006/relationships" xmlns:p="http://schemas.openxmlformats.org/presentationml/2006/main">
   <p:cSld>
     <p:bg>
@@ -19556,292 +20196,12 @@
           </a:p>
         </p:txBody>
       </p:sp>
-    </p:spTree>
-    <p:extLst>
-      <p:ext uri="{BB962C8B-B14F-4D97-AF65-F5344CB8AC3E}">
-        <p14:creationId xmlns:p14="http://schemas.microsoft.com/office/powerpoint/2010/main" val="916057669"/>
-      </p:ext>
-    </p:extLst>
-  </p:cSld>
-  <p:clrMapOvr>
-    <a:masterClrMapping/>
-  </p:clrMapOvr>
-</p:sld>
-</file>
-
-<file path=ppt/slides/slide19.xml><?xml version="1.0" encoding="utf-8"?>
-<p:sld xmlns:a="http://schemas.openxmlformats.org/drawingml/2006/main" xmlns:r="http://schemas.openxmlformats.org/officeDocument/2006/relationships" xmlns:p="http://schemas.openxmlformats.org/presentationml/2006/main">
-  <p:cSld>
-    <p:bg>
-      <p:bgPr>
-        <a:solidFill>
-          <a:schemeClr val="bg1"/>
-        </a:solidFill>
-        <a:effectLst/>
-      </p:bgPr>
-    </p:bg>
-    <p:spTree>
-      <p:nvGrpSpPr>
-        <p:cNvPr id="1" name="">
-          <a:extLst>
-            <a:ext uri="{FF2B5EF4-FFF2-40B4-BE49-F238E27FC236}">
-              <a16:creationId xmlns:a16="http://schemas.microsoft.com/office/drawing/2014/main" id="{7BC18129-AD35-8D8F-4323-77EF478FCE81}"/>
-            </a:ext>
-          </a:extLst>
-        </p:cNvPr>
-        <p:cNvGrpSpPr/>
-        <p:nvPr/>
-      </p:nvGrpSpPr>
-      <p:grpSpPr>
-        <a:xfrm>
-          <a:off x="0" y="0"/>
-          <a:ext cx="0" cy="0"/>
-          <a:chOff x="0" y="0"/>
-          <a:chExt cx="0" cy="0"/>
-        </a:xfrm>
-      </p:grpSpPr>
-      <p:sp>
-        <p:nvSpPr>
-          <p:cNvPr id="2" name="Title 1" hidden="1">
+      <p:pic>
+        <p:nvPicPr>
+          <p:cNvPr id="3" name="Picture 2">
             <a:extLst>
               <a:ext uri="{FF2B5EF4-FFF2-40B4-BE49-F238E27FC236}">
-                <a16:creationId xmlns:a16="http://schemas.microsoft.com/office/drawing/2014/main" id="{B0ACF982-D30B-A0B5-0BE2-923B1F92E274}"/>
-              </a:ext>
-            </a:extLst>
-          </p:cNvPr>
-          <p:cNvSpPr>
-            <a:spLocks noGrp="1"/>
-          </p:cNvSpPr>
-          <p:nvPr>
-            <p:ph type="title"/>
-          </p:nvPr>
-        </p:nvSpPr>
-        <p:spPr/>
-        <p:txBody>
-          <a:bodyPr/>
-          <a:lstStyle/>
-          <a:p>
-            <a:r>
-              <a:rPr lang="en-US" dirty="0"/>
-              <a:t>Cover Page</a:t>
-            </a:r>
-          </a:p>
-        </p:txBody>
-      </p:sp>
-      <p:sp>
-        <p:nvSpPr>
-          <p:cNvPr id="8" name="Title 1">
-            <a:extLst>
-              <a:ext uri="{FF2B5EF4-FFF2-40B4-BE49-F238E27FC236}">
-                <a16:creationId xmlns:a16="http://schemas.microsoft.com/office/drawing/2014/main" id="{94C7D1FE-CC59-998E-68C3-1BD53AA51ECD}"/>
-              </a:ext>
-            </a:extLst>
-          </p:cNvPr>
-          <p:cNvSpPr txBox="1">
-            <a:spLocks/>
-          </p:cNvSpPr>
-          <p:nvPr/>
-        </p:nvSpPr>
-        <p:spPr>
-          <a:xfrm>
-            <a:off x="1161975" y="151635"/>
-            <a:ext cx="7804774" cy="719719"/>
-          </a:xfrm>
-          <a:prstGeom prst="rect">
-            <a:avLst/>
-          </a:prstGeom>
-        </p:spPr>
-        <p:txBody>
-          <a:bodyPr vert="horz" lIns="0" tIns="0" rIns="0" bIns="0" rtlCol="0" anchor="t">
-            <a:noAutofit/>
-          </a:bodyPr>
-          <a:lstStyle>
-            <a:lvl1pPr algn="ctr" defTabSz="754380" rtl="0" eaLnBrk="1" latinLnBrk="0" hangingPunct="1">
-              <a:lnSpc>
-                <a:spcPct val="90000"/>
-              </a:lnSpc>
-              <a:spcBef>
-                <a:spcPct val="0"/>
-              </a:spcBef>
-              <a:buNone/>
-              <a:defRPr sz="4000" kern="1200">
-                <a:solidFill>
-                  <a:schemeClr val="tx1"/>
-                </a:solidFill>
-                <a:latin typeface="+mj-lt"/>
-                <a:ea typeface="+mj-ea"/>
-                <a:cs typeface="+mj-cs"/>
-              </a:defRPr>
-            </a:lvl1pPr>
-          </a:lstStyle>
-          <a:p>
-            <a:pPr>
-              <a:lnSpc>
-                <a:spcPct val="75000"/>
-              </a:lnSpc>
-            </a:pPr>
-            <a:r>
-              <a:rPr lang="en-US" sz="6000" u="sng" dirty="0">
-                <a:ln w="41275">
-                  <a:noFill/>
-                </a:ln>
-                <a:solidFill>
-                  <a:schemeClr val="accent2"/>
-                </a:solidFill>
-                <a:ea typeface="Source Sans Pro Black"/>
-              </a:rPr>
-              <a:t>Website</a:t>
-            </a:r>
-          </a:p>
-          <a:p>
-            <a:pPr>
-              <a:lnSpc>
-                <a:spcPct val="75000"/>
-              </a:lnSpc>
-            </a:pPr>
-            <a:r>
-              <a:rPr lang="en-US" sz="3200" dirty="0">
-                <a:ln w="41275">
-                  <a:noFill/>
-                </a:ln>
-                <a:solidFill>
-                  <a:schemeClr val="tx1">
-                    <a:lumMod val="76000"/>
-                    <a:lumOff val="24000"/>
-                  </a:schemeClr>
-                </a:solidFill>
-                <a:ea typeface="Source Sans Pro Black"/>
-              </a:rPr>
-              <a:t>Now you try</a:t>
-            </a:r>
-            <a:endParaRPr lang="en-US" sz="3200" u="sng" dirty="0">
-              <a:ln w="41275">
-                <a:noFill/>
-              </a:ln>
-              <a:solidFill>
-                <a:schemeClr val="tx1">
-                  <a:lumMod val="76000"/>
-                  <a:lumOff val="24000"/>
-                </a:schemeClr>
-              </a:solidFill>
-              <a:ea typeface="Source Sans Pro Black"/>
-            </a:endParaRPr>
-          </a:p>
-        </p:txBody>
-      </p:sp>
-      <p:cxnSp>
-        <p:nvCxnSpPr>
-          <p:cNvPr id="47" name="Straight Connector 46">
-            <a:extLst>
-              <a:ext uri="{FF2B5EF4-FFF2-40B4-BE49-F238E27FC236}">
-                <a16:creationId xmlns:a16="http://schemas.microsoft.com/office/drawing/2014/main" id="{76FD6A2C-0DF1-6F56-FC5C-B5F79B417FA2}"/>
-              </a:ext>
-              <a:ext uri="{C183D7F6-B498-43B3-948B-1728B52AA6E4}">
-                <adec:decorative xmlns:adec="http://schemas.microsoft.com/office/drawing/2017/decorative" val="1"/>
-              </a:ext>
-            </a:extLst>
-          </p:cNvPr>
-          <p:cNvCxnSpPr>
-            <a:cxnSpLocks/>
-          </p:cNvCxnSpPr>
-          <p:nvPr/>
-        </p:nvCxnSpPr>
-        <p:spPr>
-          <a:xfrm>
-            <a:off x="839615" y="1271285"/>
-            <a:ext cx="8677751" cy="0"/>
-          </a:xfrm>
-          <a:prstGeom prst="line">
-            <a:avLst/>
-          </a:prstGeom>
-          <a:ln w="25400">
-            <a:solidFill>
-              <a:schemeClr val="accent2"/>
-            </a:solidFill>
-          </a:ln>
-        </p:spPr>
-        <p:style>
-          <a:lnRef idx="1">
-            <a:schemeClr val="accent1"/>
-          </a:lnRef>
-          <a:fillRef idx="0">
-            <a:schemeClr val="accent1"/>
-          </a:fillRef>
-          <a:effectRef idx="0">
-            <a:schemeClr val="accent1"/>
-          </a:effectRef>
-          <a:fontRef idx="minor">
-            <a:schemeClr val="tx1"/>
-          </a:fontRef>
-        </p:style>
-      </p:cxnSp>
-      <p:sp>
-        <p:nvSpPr>
-          <p:cNvPr id="4" name="TextBox 3">
-            <a:extLst>
-              <a:ext uri="{FF2B5EF4-FFF2-40B4-BE49-F238E27FC236}">
-                <a16:creationId xmlns:a16="http://schemas.microsoft.com/office/drawing/2014/main" id="{6D634C00-33F6-ED3B-39D9-7C187DEBE2EE}"/>
-              </a:ext>
-            </a:extLst>
-          </p:cNvPr>
-          <p:cNvSpPr txBox="1"/>
-          <p:nvPr/>
-        </p:nvSpPr>
-        <p:spPr>
-          <a:xfrm>
-            <a:off x="2904721" y="2006982"/>
-            <a:ext cx="5029200" cy="401007"/>
-          </a:xfrm>
-          <a:prstGeom prst="rect">
-            <a:avLst/>
-          </a:prstGeom>
-          <a:noFill/>
-        </p:spPr>
-        <p:txBody>
-          <a:bodyPr wrap="square">
-            <a:spAutoFit/>
-          </a:bodyPr>
-          <a:lstStyle/>
-          <a:p>
-            <a:pPr algn="just"/>
-            <a:r>
-              <a:rPr lang="en-US" dirty="0"/>
-              <a:t>Head over to </a:t>
-            </a:r>
-            <a:r>
-              <a:rPr lang="en-001" dirty="0">
-                <a:hlinkClick r:id="rId2"/>
-              </a:rPr>
-              <a:t>http://localhost:</a:t>
-            </a:r>
-            <a:r>
-              <a:rPr lang="en-US" dirty="0">
-                <a:hlinkClick r:id="rId2"/>
-              </a:rPr>
-              <a:t>3</a:t>
-            </a:r>
-            <a:r>
-              <a:rPr lang="en-001" dirty="0">
-                <a:hlinkClick r:id="rId2"/>
-              </a:rPr>
-              <a:t>00</a:t>
-            </a:r>
-            <a:r>
-              <a:rPr lang="en-US" dirty="0">
-                <a:hlinkClick r:id="rId2"/>
-              </a:rPr>
-              <a:t>0/</a:t>
-            </a:r>
-            <a:endParaRPr lang="en-001" dirty="0"/>
-          </a:p>
-        </p:txBody>
-      </p:sp>
-      <p:pic>
-        <p:nvPicPr>
-          <p:cNvPr id="5" name="Picture 4">
-            <a:extLst>
-              <a:ext uri="{FF2B5EF4-FFF2-40B4-BE49-F238E27FC236}">
-                <a16:creationId xmlns:a16="http://schemas.microsoft.com/office/drawing/2014/main" id="{E0838244-AF26-1FD2-3F39-D30FFFC108EE}"/>
+                <a16:creationId xmlns:a16="http://schemas.microsoft.com/office/drawing/2014/main" id="{E8FF45A1-5388-96D3-9151-38D80B3B5EE8}"/>
               </a:ext>
             </a:extLst>
           </p:cNvPr>
@@ -19858,8 +20218,8 @@
         </p:blipFill>
         <p:spPr>
           <a:xfrm>
-            <a:off x="873303" y="2977198"/>
-            <a:ext cx="8311793" cy="2433693"/>
+            <a:off x="2420653" y="68327"/>
+            <a:ext cx="904996" cy="1117831"/>
           </a:xfrm>
           <a:prstGeom prst="rect">
             <a:avLst/>
@@ -19869,7 +20229,7 @@
     </p:spTree>
     <p:extLst>
       <p:ext uri="{BB962C8B-B14F-4D97-AF65-F5344CB8AC3E}">
-        <p14:creationId xmlns:p14="http://schemas.microsoft.com/office/powerpoint/2010/main" val="767257223"/>
+        <p14:creationId xmlns:p14="http://schemas.microsoft.com/office/powerpoint/2010/main" val="916057669"/>
       </p:ext>
     </p:extLst>
   </p:cSld>
@@ -24548,6 +24908,436 @@
         <p:cNvPr id="1" name="">
           <a:extLst>
             <a:ext uri="{FF2B5EF4-FFF2-40B4-BE49-F238E27FC236}">
+              <a16:creationId xmlns:a16="http://schemas.microsoft.com/office/drawing/2014/main" id="{7BC18129-AD35-8D8F-4323-77EF478FCE81}"/>
+            </a:ext>
+          </a:extLst>
+        </p:cNvPr>
+        <p:cNvGrpSpPr/>
+        <p:nvPr/>
+      </p:nvGrpSpPr>
+      <p:grpSpPr>
+        <a:xfrm>
+          <a:off x="0" y="0"/>
+          <a:ext cx="0" cy="0"/>
+          <a:chOff x="0" y="0"/>
+          <a:chExt cx="0" cy="0"/>
+        </a:xfrm>
+      </p:grpSpPr>
+      <p:sp>
+        <p:nvSpPr>
+          <p:cNvPr id="2" name="Title 1" hidden="1">
+            <a:extLst>
+              <a:ext uri="{FF2B5EF4-FFF2-40B4-BE49-F238E27FC236}">
+                <a16:creationId xmlns:a16="http://schemas.microsoft.com/office/drawing/2014/main" id="{B0ACF982-D30B-A0B5-0BE2-923B1F92E274}"/>
+              </a:ext>
+            </a:extLst>
+          </p:cNvPr>
+          <p:cNvSpPr>
+            <a:spLocks noGrp="1"/>
+          </p:cNvSpPr>
+          <p:nvPr>
+            <p:ph type="title"/>
+          </p:nvPr>
+        </p:nvSpPr>
+        <p:spPr/>
+        <p:txBody>
+          <a:bodyPr/>
+          <a:lstStyle/>
+          <a:p>
+            <a:r>
+              <a:rPr lang="en-US" dirty="0"/>
+              <a:t>Cover Page</a:t>
+            </a:r>
+          </a:p>
+        </p:txBody>
+      </p:sp>
+      <p:sp>
+        <p:nvSpPr>
+          <p:cNvPr id="8" name="Title 1">
+            <a:extLst>
+              <a:ext uri="{FF2B5EF4-FFF2-40B4-BE49-F238E27FC236}">
+                <a16:creationId xmlns:a16="http://schemas.microsoft.com/office/drawing/2014/main" id="{94C7D1FE-CC59-998E-68C3-1BD53AA51ECD}"/>
+              </a:ext>
+            </a:extLst>
+          </p:cNvPr>
+          <p:cNvSpPr txBox="1">
+            <a:spLocks/>
+          </p:cNvSpPr>
+          <p:nvPr/>
+        </p:nvSpPr>
+        <p:spPr>
+          <a:xfrm>
+            <a:off x="1161975" y="151635"/>
+            <a:ext cx="7804774" cy="719719"/>
+          </a:xfrm>
+          <a:prstGeom prst="rect">
+            <a:avLst/>
+          </a:prstGeom>
+        </p:spPr>
+        <p:txBody>
+          <a:bodyPr vert="horz" lIns="0" tIns="0" rIns="0" bIns="0" rtlCol="0" anchor="t">
+            <a:noAutofit/>
+          </a:bodyPr>
+          <a:lstStyle>
+            <a:lvl1pPr algn="ctr" defTabSz="754380" rtl="0" eaLnBrk="1" latinLnBrk="0" hangingPunct="1">
+              <a:lnSpc>
+                <a:spcPct val="90000"/>
+              </a:lnSpc>
+              <a:spcBef>
+                <a:spcPct val="0"/>
+              </a:spcBef>
+              <a:buNone/>
+              <a:defRPr sz="4000" kern="1200">
+                <a:solidFill>
+                  <a:schemeClr val="tx1"/>
+                </a:solidFill>
+                <a:latin typeface="+mj-lt"/>
+                <a:ea typeface="+mj-ea"/>
+                <a:cs typeface="+mj-cs"/>
+              </a:defRPr>
+            </a:lvl1pPr>
+          </a:lstStyle>
+          <a:p>
+            <a:pPr>
+              <a:lnSpc>
+                <a:spcPct val="75000"/>
+              </a:lnSpc>
+            </a:pPr>
+            <a:r>
+              <a:rPr lang="en-US" sz="6000" u="sng" dirty="0">
+                <a:ln w="41275">
+                  <a:noFill/>
+                </a:ln>
+                <a:solidFill>
+                  <a:schemeClr val="accent2"/>
+                </a:solidFill>
+                <a:ea typeface="Source Sans Pro Black"/>
+              </a:rPr>
+              <a:t>Website</a:t>
+            </a:r>
+          </a:p>
+          <a:p>
+            <a:pPr>
+              <a:lnSpc>
+                <a:spcPct val="75000"/>
+              </a:lnSpc>
+            </a:pPr>
+            <a:r>
+              <a:rPr lang="en-US" sz="3200" dirty="0">
+                <a:ln w="41275">
+                  <a:noFill/>
+                </a:ln>
+                <a:solidFill>
+                  <a:schemeClr val="tx1">
+                    <a:lumMod val="76000"/>
+                    <a:lumOff val="24000"/>
+                  </a:schemeClr>
+                </a:solidFill>
+                <a:ea typeface="Source Sans Pro Black"/>
+              </a:rPr>
+              <a:t>Now you try</a:t>
+            </a:r>
+            <a:endParaRPr lang="en-US" sz="3200" u="sng" dirty="0">
+              <a:ln w="41275">
+                <a:noFill/>
+              </a:ln>
+              <a:solidFill>
+                <a:schemeClr val="tx1">
+                  <a:lumMod val="76000"/>
+                  <a:lumOff val="24000"/>
+                </a:schemeClr>
+              </a:solidFill>
+              <a:ea typeface="Source Sans Pro Black"/>
+            </a:endParaRPr>
+          </a:p>
+        </p:txBody>
+      </p:sp>
+      <p:cxnSp>
+        <p:nvCxnSpPr>
+          <p:cNvPr id="47" name="Straight Connector 46">
+            <a:extLst>
+              <a:ext uri="{FF2B5EF4-FFF2-40B4-BE49-F238E27FC236}">
+                <a16:creationId xmlns:a16="http://schemas.microsoft.com/office/drawing/2014/main" id="{76FD6A2C-0DF1-6F56-FC5C-B5F79B417FA2}"/>
+              </a:ext>
+              <a:ext uri="{C183D7F6-B498-43B3-948B-1728B52AA6E4}">
+                <adec:decorative xmlns:adec="http://schemas.microsoft.com/office/drawing/2017/decorative" val="1"/>
+              </a:ext>
+            </a:extLst>
+          </p:cNvPr>
+          <p:cNvCxnSpPr>
+            <a:cxnSpLocks/>
+          </p:cNvCxnSpPr>
+          <p:nvPr/>
+        </p:nvCxnSpPr>
+        <p:spPr>
+          <a:xfrm>
+            <a:off x="839615" y="1271285"/>
+            <a:ext cx="8677751" cy="0"/>
+          </a:xfrm>
+          <a:prstGeom prst="line">
+            <a:avLst/>
+          </a:prstGeom>
+          <a:ln w="25400">
+            <a:solidFill>
+              <a:schemeClr val="accent2"/>
+            </a:solidFill>
+          </a:ln>
+        </p:spPr>
+        <p:style>
+          <a:lnRef idx="1">
+            <a:schemeClr val="accent1"/>
+          </a:lnRef>
+          <a:fillRef idx="0">
+            <a:schemeClr val="accent1"/>
+          </a:fillRef>
+          <a:effectRef idx="0">
+            <a:schemeClr val="accent1"/>
+          </a:effectRef>
+          <a:fontRef idx="minor">
+            <a:schemeClr val="tx1"/>
+          </a:fontRef>
+        </p:style>
+      </p:cxnSp>
+      <p:sp>
+        <p:nvSpPr>
+          <p:cNvPr id="4" name="TextBox 3">
+            <a:extLst>
+              <a:ext uri="{FF2B5EF4-FFF2-40B4-BE49-F238E27FC236}">
+                <a16:creationId xmlns:a16="http://schemas.microsoft.com/office/drawing/2014/main" id="{6D634C00-33F6-ED3B-39D9-7C187DEBE2EE}"/>
+              </a:ext>
+            </a:extLst>
+          </p:cNvPr>
+          <p:cNvSpPr txBox="1"/>
+          <p:nvPr/>
+        </p:nvSpPr>
+        <p:spPr>
+          <a:xfrm>
+            <a:off x="2904721" y="2006982"/>
+            <a:ext cx="5029200" cy="401007"/>
+          </a:xfrm>
+          <a:prstGeom prst="rect">
+            <a:avLst/>
+          </a:prstGeom>
+          <a:noFill/>
+        </p:spPr>
+        <p:txBody>
+          <a:bodyPr wrap="square">
+            <a:spAutoFit/>
+          </a:bodyPr>
+          <a:lstStyle/>
+          <a:p>
+            <a:pPr algn="just"/>
+            <a:r>
+              <a:rPr lang="en-US" dirty="0"/>
+              <a:t>Head over to </a:t>
+            </a:r>
+            <a:r>
+              <a:rPr lang="en-001" dirty="0">
+                <a:hlinkClick r:id="rId2"/>
+              </a:rPr>
+              <a:t>http://localhost:</a:t>
+            </a:r>
+            <a:r>
+              <a:rPr lang="en-US" dirty="0">
+                <a:hlinkClick r:id="rId2"/>
+              </a:rPr>
+              <a:t>3</a:t>
+            </a:r>
+            <a:r>
+              <a:rPr lang="en-001" dirty="0">
+                <a:hlinkClick r:id="rId2"/>
+              </a:rPr>
+              <a:t>00</a:t>
+            </a:r>
+            <a:r>
+              <a:rPr lang="en-US" dirty="0">
+                <a:hlinkClick r:id="rId2"/>
+              </a:rPr>
+              <a:t>0/</a:t>
+            </a:r>
+            <a:endParaRPr lang="en-001" dirty="0"/>
+          </a:p>
+        </p:txBody>
+      </p:sp>
+      <p:pic>
+        <p:nvPicPr>
+          <p:cNvPr id="5" name="Picture 4">
+            <a:extLst>
+              <a:ext uri="{FF2B5EF4-FFF2-40B4-BE49-F238E27FC236}">
+                <a16:creationId xmlns:a16="http://schemas.microsoft.com/office/drawing/2014/main" id="{E0838244-AF26-1FD2-3F39-D30FFFC108EE}"/>
+              </a:ext>
+            </a:extLst>
+          </p:cNvPr>
+          <p:cNvPicPr>
+            <a:picLocks noChangeAspect="1"/>
+          </p:cNvPicPr>
+          <p:nvPr/>
+        </p:nvPicPr>
+        <p:blipFill>
+          <a:blip r:embed="rId3"/>
+          <a:stretch>
+            <a:fillRect/>
+          </a:stretch>
+        </p:blipFill>
+        <p:spPr>
+          <a:xfrm>
+            <a:off x="873303" y="2977198"/>
+            <a:ext cx="8311793" cy="2433693"/>
+          </a:xfrm>
+          <a:prstGeom prst="rect">
+            <a:avLst/>
+          </a:prstGeom>
+        </p:spPr>
+      </p:pic>
+      <p:sp>
+        <p:nvSpPr>
+          <p:cNvPr id="3" name="AutoShape 2" descr="Smiling computer robot character">
+            <a:extLst>
+              <a:ext uri="{FF2B5EF4-FFF2-40B4-BE49-F238E27FC236}">
+                <a16:creationId xmlns:a16="http://schemas.microsoft.com/office/drawing/2014/main" id="{9D9882B1-808A-3688-05DC-5057728689EC}"/>
+              </a:ext>
+            </a:extLst>
+          </p:cNvPr>
+          <p:cNvSpPr>
+            <a:spLocks noChangeAspect="1" noChangeArrowheads="1"/>
+          </p:cNvSpPr>
+          <p:nvPr/>
+        </p:nvSpPr>
+        <p:spPr bwMode="auto">
+          <a:xfrm>
+            <a:off x="4876800" y="3733800"/>
+            <a:ext cx="304800" cy="304800"/>
+          </a:xfrm>
+          <a:prstGeom prst="rect">
+            <a:avLst/>
+          </a:prstGeom>
+          <a:noFill/>
+          <a:extLst>
+            <a:ext uri="{909E8E84-426E-40DD-AFC4-6F175D3DCCD1}">
+              <a14:hiddenFill xmlns:a14="http://schemas.microsoft.com/office/drawing/2010/main">
+                <a:solidFill>
+                  <a:srgbClr val="FFFFFF"/>
+                </a:solidFill>
+              </a14:hiddenFill>
+            </a:ext>
+          </a:extLst>
+        </p:spPr>
+        <p:txBody>
+          <a:bodyPr vert="horz" wrap="square" lIns="91440" tIns="45720" rIns="91440" bIns="45720" numCol="1" anchor="t" anchorCtr="0" compatLnSpc="1">
+            <a:prstTxWarp prst="textNoShape">
+              <a:avLst/>
+            </a:prstTxWarp>
+          </a:bodyPr>
+          <a:lstStyle/>
+          <a:p>
+            <a:endParaRPr lang="en-001"/>
+          </a:p>
+        </p:txBody>
+      </p:sp>
+      <p:sp>
+        <p:nvSpPr>
+          <p:cNvPr id="10" name="AutoShape 6" descr="Smiling computer robot character">
+            <a:extLst>
+              <a:ext uri="{FF2B5EF4-FFF2-40B4-BE49-F238E27FC236}">
+                <a16:creationId xmlns:a16="http://schemas.microsoft.com/office/drawing/2014/main" id="{1953AEDF-E224-BD32-8532-BEDA26725252}"/>
+              </a:ext>
+            </a:extLst>
+          </p:cNvPr>
+          <p:cNvSpPr>
+            <a:spLocks noChangeAspect="1" noChangeArrowheads="1"/>
+          </p:cNvSpPr>
+          <p:nvPr/>
+        </p:nvSpPr>
+        <p:spPr bwMode="auto">
+          <a:xfrm>
+            <a:off x="5029200" y="3886200"/>
+            <a:ext cx="304800" cy="304800"/>
+          </a:xfrm>
+          <a:prstGeom prst="rect">
+            <a:avLst/>
+          </a:prstGeom>
+          <a:noFill/>
+          <a:extLst>
+            <a:ext uri="{909E8E84-426E-40DD-AFC4-6F175D3DCCD1}">
+              <a14:hiddenFill xmlns:a14="http://schemas.microsoft.com/office/drawing/2010/main">
+                <a:solidFill>
+                  <a:srgbClr val="FFFFFF"/>
+                </a:solidFill>
+              </a14:hiddenFill>
+            </a:ext>
+          </a:extLst>
+        </p:spPr>
+        <p:txBody>
+          <a:bodyPr vert="horz" wrap="square" lIns="91440" tIns="45720" rIns="91440" bIns="45720" numCol="1" anchor="t" anchorCtr="0" compatLnSpc="1">
+            <a:prstTxWarp prst="textNoShape">
+              <a:avLst/>
+            </a:prstTxWarp>
+          </a:bodyPr>
+          <a:lstStyle/>
+          <a:p>
+            <a:endParaRPr lang="en-001"/>
+          </a:p>
+        </p:txBody>
+      </p:sp>
+      <p:pic>
+        <p:nvPicPr>
+          <p:cNvPr id="12" name="Picture 11">
+            <a:extLst>
+              <a:ext uri="{FF2B5EF4-FFF2-40B4-BE49-F238E27FC236}">
+                <a16:creationId xmlns:a16="http://schemas.microsoft.com/office/drawing/2014/main" id="{69C6A778-662A-4EE9-9E3A-FDDD454948CA}"/>
+              </a:ext>
+            </a:extLst>
+          </p:cNvPr>
+          <p:cNvPicPr>
+            <a:picLocks noChangeAspect="1"/>
+          </p:cNvPicPr>
+          <p:nvPr/>
+        </p:nvPicPr>
+        <p:blipFill>
+          <a:blip r:embed="rId4"/>
+          <a:stretch>
+            <a:fillRect/>
+          </a:stretch>
+        </p:blipFill>
+        <p:spPr>
+          <a:xfrm>
+            <a:off x="6917098" y="1840495"/>
+            <a:ext cx="1421985" cy="1048069"/>
+          </a:xfrm>
+          <a:prstGeom prst="rect">
+            <a:avLst/>
+          </a:prstGeom>
+        </p:spPr>
+      </p:pic>
+    </p:spTree>
+    <p:extLst>
+      <p:ext uri="{BB962C8B-B14F-4D97-AF65-F5344CB8AC3E}">
+        <p14:creationId xmlns:p14="http://schemas.microsoft.com/office/powerpoint/2010/main" val="767257223"/>
+      </p:ext>
+    </p:extLst>
+  </p:cSld>
+  <p:clrMapOvr>
+    <a:masterClrMapping/>
+  </p:clrMapOvr>
+</p:sld>
+</file>
+
+<file path=ppt/slides/slide21.xml><?xml version="1.0" encoding="utf-8"?>
+<p:sld xmlns:a="http://schemas.openxmlformats.org/drawingml/2006/main" xmlns:r="http://schemas.openxmlformats.org/officeDocument/2006/relationships" xmlns:p="http://schemas.openxmlformats.org/presentationml/2006/main">
+  <p:cSld>
+    <p:bg>
+      <p:bgPr>
+        <a:solidFill>
+          <a:schemeClr val="bg1"/>
+        </a:solidFill>
+        <a:effectLst/>
+      </p:bgPr>
+    </p:bg>
+    <p:spTree>
+      <p:nvGrpSpPr>
+        <p:cNvPr id="1" name="">
+          <a:extLst>
+            <a:ext uri="{FF2B5EF4-FFF2-40B4-BE49-F238E27FC236}">
               <a16:creationId xmlns:a16="http://schemas.microsoft.com/office/drawing/2014/main" id="{1AE891E2-3DEB-70ED-5E82-C981D8871A27}"/>
             </a:ext>
           </a:extLst>
@@ -24845,6 +25635,36 @@
           </a:fontRef>
         </p:style>
       </p:cxnSp>
+      <p:pic>
+        <p:nvPicPr>
+          <p:cNvPr id="3" name="Picture 2">
+            <a:extLst>
+              <a:ext uri="{FF2B5EF4-FFF2-40B4-BE49-F238E27FC236}">
+                <a16:creationId xmlns:a16="http://schemas.microsoft.com/office/drawing/2014/main" id="{B11A71E8-6CAF-EF71-2087-306E30E7BA87}"/>
+              </a:ext>
+            </a:extLst>
+          </p:cNvPr>
+          <p:cNvPicPr>
+            <a:picLocks noChangeAspect="1"/>
+          </p:cNvPicPr>
+          <p:nvPr/>
+        </p:nvPicPr>
+        <p:blipFill>
+          <a:blip r:embed="rId3"/>
+          <a:stretch>
+            <a:fillRect/>
+          </a:stretch>
+        </p:blipFill>
+        <p:spPr>
+          <a:xfrm>
+            <a:off x="4195388" y="5767539"/>
+            <a:ext cx="1421985" cy="1048069"/>
+          </a:xfrm>
+          <a:prstGeom prst="rect">
+            <a:avLst/>
+          </a:prstGeom>
+        </p:spPr>
+      </p:pic>
     </p:spTree>
     <p:extLst>
       <p:ext uri="{BB962C8B-B14F-4D97-AF65-F5344CB8AC3E}">
@@ -24858,7 +25678,7 @@
 </p:sld>
 </file>
 
-<file path=ppt/slides/slide21.xml><?xml version="1.0" encoding="utf-8"?>
+<file path=ppt/slides/slide22.xml><?xml version="1.0" encoding="utf-8"?>
 <p:sld xmlns:a="http://schemas.openxmlformats.org/drawingml/2006/main" xmlns:r="http://schemas.openxmlformats.org/officeDocument/2006/relationships" xmlns:p="http://schemas.openxmlformats.org/presentationml/2006/main">
   <p:cSld>
     <p:bg>
@@ -25094,6 +25914,36 @@
           </a:prstGeom>
         </p:spPr>
       </p:pic>
+      <p:pic>
+        <p:nvPicPr>
+          <p:cNvPr id="3" name="Picture 2">
+            <a:extLst>
+              <a:ext uri="{FF2B5EF4-FFF2-40B4-BE49-F238E27FC236}">
+                <a16:creationId xmlns:a16="http://schemas.microsoft.com/office/drawing/2014/main" id="{ABF0490B-0629-3D27-3C41-4625FBB3A10A}"/>
+              </a:ext>
+            </a:extLst>
+          </p:cNvPr>
+          <p:cNvPicPr>
+            <a:picLocks noChangeAspect="1"/>
+          </p:cNvPicPr>
+          <p:nvPr/>
+        </p:nvPicPr>
+        <p:blipFill>
+          <a:blip r:embed="rId3"/>
+          <a:stretch>
+            <a:fillRect/>
+          </a:stretch>
+        </p:blipFill>
+        <p:spPr>
+          <a:xfrm>
+            <a:off x="8540416" y="3362165"/>
+            <a:ext cx="1421985" cy="1048069"/>
+          </a:xfrm>
+          <a:prstGeom prst="rect">
+            <a:avLst/>
+          </a:prstGeom>
+        </p:spPr>
+      </p:pic>
     </p:spTree>
     <p:extLst>
       <p:ext uri="{BB962C8B-B14F-4D97-AF65-F5344CB8AC3E}">
@@ -25107,7 +25957,7 @@
 </p:sld>
 </file>
 
-<file path=ppt/slides/slide22.xml><?xml version="1.0" encoding="utf-8"?>
+<file path=ppt/slides/slide23.xml><?xml version="1.0" encoding="utf-8"?>
 <p:sld xmlns:a="http://schemas.openxmlformats.org/drawingml/2006/main" xmlns:r="http://schemas.openxmlformats.org/officeDocument/2006/relationships" xmlns:p="http://schemas.openxmlformats.org/presentationml/2006/main">
   <p:cSld>
     <p:spTree>
@@ -25480,6 +26330,36 @@
           </a:prstGeom>
         </p:spPr>
       </p:pic>
+      <p:pic>
+        <p:nvPicPr>
+          <p:cNvPr id="3" name="Picture 2">
+            <a:extLst>
+              <a:ext uri="{FF2B5EF4-FFF2-40B4-BE49-F238E27FC236}">
+                <a16:creationId xmlns:a16="http://schemas.microsoft.com/office/drawing/2014/main" id="{E49C729A-749F-AA0E-90F3-81CC360C00CD}"/>
+              </a:ext>
+            </a:extLst>
+          </p:cNvPr>
+          <p:cNvPicPr>
+            <a:picLocks noChangeAspect="1"/>
+          </p:cNvPicPr>
+          <p:nvPr/>
+        </p:nvPicPr>
+        <p:blipFill>
+          <a:blip r:embed="rId6"/>
+          <a:stretch>
+            <a:fillRect/>
+          </a:stretch>
+        </p:blipFill>
+        <p:spPr>
+          <a:xfrm flipH="1">
+            <a:off x="1021825" y="134582"/>
+            <a:ext cx="904996" cy="1117831"/>
+          </a:xfrm>
+          <a:prstGeom prst="rect">
+            <a:avLst/>
+          </a:prstGeom>
+        </p:spPr>
+      </p:pic>
     </p:spTree>
     <p:extLst>
       <p:ext uri="{BB962C8B-B14F-4D97-AF65-F5344CB8AC3E}">
@@ -25493,7 +26373,7 @@
 </p:sld>
 </file>
 
-<file path=ppt/slides/slide23.xml><?xml version="1.0" encoding="utf-8"?>
+<file path=ppt/slides/slide24.xml><?xml version="1.0" encoding="utf-8"?>
 <p:sld xmlns:a="http://schemas.openxmlformats.org/drawingml/2006/main" xmlns:r="http://schemas.openxmlformats.org/officeDocument/2006/relationships" xmlns:p="http://schemas.openxmlformats.org/presentationml/2006/main">
   <p:cSld>
     <p:spTree>
@@ -25806,6 +26686,36 @@
           </a:p>
         </p:txBody>
       </p:sp>
+      <p:pic>
+        <p:nvPicPr>
+          <p:cNvPr id="3" name="Picture 2">
+            <a:extLst>
+              <a:ext uri="{FF2B5EF4-FFF2-40B4-BE49-F238E27FC236}">
+                <a16:creationId xmlns:a16="http://schemas.microsoft.com/office/drawing/2014/main" id="{3D5B4A9C-E124-5F9D-C393-1E907CE1F781}"/>
+              </a:ext>
+            </a:extLst>
+          </p:cNvPr>
+          <p:cNvPicPr>
+            <a:picLocks noChangeAspect="1"/>
+          </p:cNvPicPr>
+          <p:nvPr/>
+        </p:nvPicPr>
+        <p:blipFill>
+          <a:blip r:embed="rId3"/>
+          <a:stretch>
+            <a:fillRect/>
+          </a:stretch>
+        </p:blipFill>
+        <p:spPr>
+          <a:xfrm flipH="1">
+            <a:off x="7991429" y="39147"/>
+            <a:ext cx="904996" cy="1117831"/>
+          </a:xfrm>
+          <a:prstGeom prst="rect">
+            <a:avLst/>
+          </a:prstGeom>
+        </p:spPr>
+      </p:pic>
     </p:spTree>
     <p:extLst>
       <p:ext uri="{BB962C8B-B14F-4D97-AF65-F5344CB8AC3E}">
@@ -25819,7 +26729,7 @@
 </p:sld>
 </file>
 
-<file path=ppt/slides/slide24.xml><?xml version="1.0" encoding="utf-8"?>
+<file path=ppt/slides/slide25.xml><?xml version="1.0" encoding="utf-8"?>
 <p:sld xmlns:a="http://schemas.openxmlformats.org/drawingml/2006/main" xmlns:r="http://schemas.openxmlformats.org/officeDocument/2006/relationships" xmlns:p="http://schemas.openxmlformats.org/presentationml/2006/main">
   <p:cSld>
     <p:spTree>
@@ -26377,6 +27287,36 @@
           </a:p>
         </p:txBody>
       </p:sp>
+      <p:pic>
+        <p:nvPicPr>
+          <p:cNvPr id="3" name="Picture 2">
+            <a:extLst>
+              <a:ext uri="{FF2B5EF4-FFF2-40B4-BE49-F238E27FC236}">
+                <a16:creationId xmlns:a16="http://schemas.microsoft.com/office/drawing/2014/main" id="{B8C36475-3858-D103-7A99-0D04FBDBE7E2}"/>
+              </a:ext>
+            </a:extLst>
+          </p:cNvPr>
+          <p:cNvPicPr>
+            <a:picLocks noChangeAspect="1"/>
+          </p:cNvPicPr>
+          <p:nvPr/>
+        </p:nvPicPr>
+        <p:blipFill>
+          <a:blip r:embed="rId3"/>
+          <a:stretch>
+            <a:fillRect/>
+          </a:stretch>
+        </p:blipFill>
+        <p:spPr>
+          <a:xfrm flipH="1">
+            <a:off x="9153404" y="71118"/>
+            <a:ext cx="904996" cy="1117831"/>
+          </a:xfrm>
+          <a:prstGeom prst="rect">
+            <a:avLst/>
+          </a:prstGeom>
+        </p:spPr>
+      </p:pic>
     </p:spTree>
     <p:extLst>
       <p:ext uri="{BB962C8B-B14F-4D97-AF65-F5344CB8AC3E}">
@@ -26390,7 +27330,7 @@
 </p:sld>
 </file>
 
-<file path=ppt/slides/slide25.xml><?xml version="1.0" encoding="utf-8"?>
+<file path=ppt/slides/slide26.xml><?xml version="1.0" encoding="utf-8"?>
 <p:sld xmlns:a="http://schemas.openxmlformats.org/drawingml/2006/main" xmlns:r="http://schemas.openxmlformats.org/officeDocument/2006/relationships" xmlns:p="http://schemas.openxmlformats.org/presentationml/2006/main">
   <p:cSld>
     <p:spTree>
@@ -26644,7 +27584,7 @@
 </p:sld>
 </file>
 
-<file path=ppt/slides/slide26.xml><?xml version="1.0" encoding="utf-8"?>
+<file path=ppt/slides/slide27.xml><?xml version="1.0" encoding="utf-8"?>
 <p:sld xmlns:a="http://schemas.openxmlformats.org/drawingml/2006/main" xmlns:r="http://schemas.openxmlformats.org/officeDocument/2006/relationships" xmlns:p="http://schemas.openxmlformats.org/presentationml/2006/main">
   <p:cSld>
     <p:spTree>
@@ -26955,8 +27895,12 @@
           <a:lstStyle/>
           <a:p>
             <a:r>
+              <a:rPr lang="en-US" u="sng" dirty="0"/>
+              <a:t>Inside</a:t>
+            </a:r>
+            <a:r>
               <a:rPr lang="en-US" dirty="0"/>
-              <a:t>Inside: </a:t>
+              <a:t>: </a:t>
             </a:r>
             <a:r>
               <a:rPr lang="en-US" b="1" dirty="0"/>
@@ -26977,10 +27921,420 @@
           </a:p>
         </p:txBody>
       </p:sp>
+      <p:pic>
+        <p:nvPicPr>
+          <p:cNvPr id="4" name="Picture 3">
+            <a:extLst>
+              <a:ext uri="{FF2B5EF4-FFF2-40B4-BE49-F238E27FC236}">
+                <a16:creationId xmlns:a16="http://schemas.microsoft.com/office/drawing/2014/main" id="{3BA8F793-8D75-C54D-AE73-B58E97FFD8CF}"/>
+              </a:ext>
+            </a:extLst>
+          </p:cNvPr>
+          <p:cNvPicPr>
+            <a:picLocks noChangeAspect="1"/>
+          </p:cNvPicPr>
+          <p:nvPr/>
+        </p:nvPicPr>
+        <p:blipFill>
+          <a:blip r:embed="rId3"/>
+          <a:stretch>
+            <a:fillRect/>
+          </a:stretch>
+        </p:blipFill>
+        <p:spPr>
+          <a:xfrm>
+            <a:off x="8384599" y="0"/>
+            <a:ext cx="1132767" cy="1103768"/>
+          </a:xfrm>
+          <a:prstGeom prst="rect">
+            <a:avLst/>
+          </a:prstGeom>
+        </p:spPr>
+      </p:pic>
     </p:spTree>
     <p:extLst>
       <p:ext uri="{BB962C8B-B14F-4D97-AF65-F5344CB8AC3E}">
         <p14:creationId xmlns:p14="http://schemas.microsoft.com/office/powerpoint/2010/main" val="2722349114"/>
+      </p:ext>
+    </p:extLst>
+  </p:cSld>
+  <p:clrMapOvr>
+    <a:masterClrMapping/>
+  </p:clrMapOvr>
+</p:sld>
+</file>
+
+<file path=ppt/slides/slide28.xml><?xml version="1.0" encoding="utf-8"?>
+<p:sld xmlns:a="http://schemas.openxmlformats.org/drawingml/2006/main" xmlns:r="http://schemas.openxmlformats.org/officeDocument/2006/relationships" xmlns:p="http://schemas.openxmlformats.org/presentationml/2006/main">
+  <p:cSld>
+    <p:spTree>
+      <p:nvGrpSpPr>
+        <p:cNvPr id="1" name="">
+          <a:extLst>
+            <a:ext uri="{FF2B5EF4-FFF2-40B4-BE49-F238E27FC236}">
+              <a16:creationId xmlns:a16="http://schemas.microsoft.com/office/drawing/2014/main" id="{7E63E60D-C0A3-0490-4B87-BB7B0AB9CD77}"/>
+            </a:ext>
+          </a:extLst>
+        </p:cNvPr>
+        <p:cNvGrpSpPr/>
+        <p:nvPr/>
+      </p:nvGrpSpPr>
+      <p:grpSpPr>
+        <a:xfrm>
+          <a:off x="0" y="0"/>
+          <a:ext cx="0" cy="0"/>
+          <a:chOff x="0" y="0"/>
+          <a:chExt cx="0" cy="0"/>
+        </a:xfrm>
+      </p:grpSpPr>
+      <p:sp>
+        <p:nvSpPr>
+          <p:cNvPr id="2" name="Title 1" hidden="1">
+            <a:extLst>
+              <a:ext uri="{FF2B5EF4-FFF2-40B4-BE49-F238E27FC236}">
+                <a16:creationId xmlns:a16="http://schemas.microsoft.com/office/drawing/2014/main" id="{6872953E-A650-3865-6509-E73EC10530F6}"/>
+              </a:ext>
+            </a:extLst>
+          </p:cNvPr>
+          <p:cNvSpPr>
+            <a:spLocks noGrp="1"/>
+          </p:cNvSpPr>
+          <p:nvPr>
+            <p:ph type="title"/>
+          </p:nvPr>
+        </p:nvSpPr>
+        <p:spPr/>
+        <p:txBody>
+          <a:bodyPr/>
+          <a:lstStyle/>
+          <a:p>
+            <a:r>
+              <a:rPr lang="en-US" dirty="0"/>
+              <a:t>Cover Page</a:t>
+            </a:r>
+          </a:p>
+        </p:txBody>
+      </p:sp>
+      <p:sp>
+        <p:nvSpPr>
+          <p:cNvPr id="8" name="Title 1">
+            <a:extLst>
+              <a:ext uri="{FF2B5EF4-FFF2-40B4-BE49-F238E27FC236}">
+                <a16:creationId xmlns:a16="http://schemas.microsoft.com/office/drawing/2014/main" id="{7EE46A6F-A96B-F9CF-A0FB-9A0C838C6EEA}"/>
+              </a:ext>
+            </a:extLst>
+          </p:cNvPr>
+          <p:cNvSpPr txBox="1">
+            <a:spLocks/>
+          </p:cNvSpPr>
+          <p:nvPr/>
+        </p:nvSpPr>
+        <p:spPr>
+          <a:xfrm>
+            <a:off x="1161975" y="151635"/>
+            <a:ext cx="7804774" cy="719719"/>
+          </a:xfrm>
+          <a:prstGeom prst="rect">
+            <a:avLst/>
+          </a:prstGeom>
+        </p:spPr>
+        <p:txBody>
+          <a:bodyPr vert="horz" lIns="0" tIns="0" rIns="0" bIns="0" rtlCol="0" anchor="t">
+            <a:noAutofit/>
+          </a:bodyPr>
+          <a:lstStyle>
+            <a:lvl1pPr algn="ctr" defTabSz="754380" rtl="0" eaLnBrk="1" latinLnBrk="0" hangingPunct="1">
+              <a:lnSpc>
+                <a:spcPct val="90000"/>
+              </a:lnSpc>
+              <a:spcBef>
+                <a:spcPct val="0"/>
+              </a:spcBef>
+              <a:buNone/>
+              <a:defRPr sz="4000" kern="1200">
+                <a:solidFill>
+                  <a:schemeClr val="tx1"/>
+                </a:solidFill>
+                <a:latin typeface="+mj-lt"/>
+                <a:ea typeface="+mj-ea"/>
+                <a:cs typeface="+mj-cs"/>
+              </a:defRPr>
+            </a:lvl1pPr>
+          </a:lstStyle>
+          <a:p>
+            <a:pPr>
+              <a:lnSpc>
+                <a:spcPct val="75000"/>
+              </a:lnSpc>
+            </a:pPr>
+            <a:r>
+              <a:rPr lang="en-US" sz="6000" u="sng" dirty="0">
+                <a:ln w="41275">
+                  <a:noFill/>
+                </a:ln>
+                <a:solidFill>
+                  <a:schemeClr val="accent2"/>
+                </a:solidFill>
+                <a:ea typeface="Source Sans Pro Black"/>
+              </a:rPr>
+              <a:t>Visual Studio Code</a:t>
+            </a:r>
+          </a:p>
+          <a:p>
+            <a:pPr>
+              <a:lnSpc>
+                <a:spcPct val="75000"/>
+              </a:lnSpc>
+            </a:pPr>
+            <a:r>
+              <a:rPr lang="en-US" sz="3200" dirty="0">
+                <a:ln w="41275">
+                  <a:noFill/>
+                </a:ln>
+                <a:solidFill>
+                  <a:schemeClr val="tx1">
+                    <a:lumMod val="76000"/>
+                    <a:lumOff val="24000"/>
+                  </a:schemeClr>
+                </a:solidFill>
+                <a:ea typeface="Source Sans Pro Black"/>
+              </a:rPr>
+              <a:t>Solution</a:t>
+            </a:r>
+            <a:endParaRPr lang="en-US" sz="3200" u="sng" dirty="0">
+              <a:ln w="41275">
+                <a:noFill/>
+              </a:ln>
+              <a:solidFill>
+                <a:schemeClr val="tx1">
+                  <a:lumMod val="76000"/>
+                  <a:lumOff val="24000"/>
+                </a:schemeClr>
+              </a:solidFill>
+              <a:ea typeface="Source Sans Pro Black"/>
+            </a:endParaRPr>
+          </a:p>
+        </p:txBody>
+      </p:sp>
+      <p:cxnSp>
+        <p:nvCxnSpPr>
+          <p:cNvPr id="47" name="Straight Connector 46">
+            <a:extLst>
+              <a:ext uri="{FF2B5EF4-FFF2-40B4-BE49-F238E27FC236}">
+                <a16:creationId xmlns:a16="http://schemas.microsoft.com/office/drawing/2014/main" id="{16B32A77-E9C9-0FA0-7363-29A897389B1E}"/>
+              </a:ext>
+              <a:ext uri="{C183D7F6-B498-43B3-948B-1728B52AA6E4}">
+                <adec:decorative xmlns:adec="http://schemas.microsoft.com/office/drawing/2017/decorative" val="1"/>
+              </a:ext>
+            </a:extLst>
+          </p:cNvPr>
+          <p:cNvCxnSpPr>
+            <a:cxnSpLocks/>
+          </p:cNvCxnSpPr>
+          <p:nvPr/>
+        </p:nvCxnSpPr>
+        <p:spPr>
+          <a:xfrm>
+            <a:off x="839615" y="1271285"/>
+            <a:ext cx="8677751" cy="0"/>
+          </a:xfrm>
+          <a:prstGeom prst="line">
+            <a:avLst/>
+          </a:prstGeom>
+          <a:ln w="25400">
+            <a:solidFill>
+              <a:schemeClr val="accent2"/>
+            </a:solidFill>
+          </a:ln>
+        </p:spPr>
+        <p:style>
+          <a:lnRef idx="1">
+            <a:schemeClr val="accent1"/>
+          </a:lnRef>
+          <a:fillRef idx="0">
+            <a:schemeClr val="accent1"/>
+          </a:fillRef>
+          <a:effectRef idx="0">
+            <a:schemeClr val="accent1"/>
+          </a:effectRef>
+          <a:fontRef idx="minor">
+            <a:schemeClr val="tx1"/>
+          </a:fontRef>
+        </p:style>
+      </p:cxnSp>
+      <p:sp>
+        <p:nvSpPr>
+          <p:cNvPr id="11" name="TextBox 10">
+            <a:extLst>
+              <a:ext uri="{FF2B5EF4-FFF2-40B4-BE49-F238E27FC236}">
+                <a16:creationId xmlns:a16="http://schemas.microsoft.com/office/drawing/2014/main" id="{3F0407E0-F732-3249-B60D-3BD8BB27C1B7}"/>
+              </a:ext>
+            </a:extLst>
+          </p:cNvPr>
+          <p:cNvSpPr txBox="1"/>
+          <p:nvPr/>
+        </p:nvSpPr>
+        <p:spPr>
+          <a:xfrm>
+            <a:off x="1520575" y="1715784"/>
+            <a:ext cx="6914072" cy="709681"/>
+          </a:xfrm>
+          <a:prstGeom prst="rect">
+            <a:avLst/>
+          </a:prstGeom>
+          <a:noFill/>
+        </p:spPr>
+        <p:txBody>
+          <a:bodyPr wrap="none" rtlCol="0">
+            <a:spAutoFit/>
+          </a:bodyPr>
+          <a:lstStyle/>
+          <a:p>
+            <a:r>
+              <a:rPr lang="en-US" i="1" u="sng" dirty="0"/>
+              <a:t>Solution inside</a:t>
+            </a:r>
+            <a:r>
+              <a:rPr lang="en-US" dirty="0"/>
+              <a:t>: </a:t>
+            </a:r>
+            <a:r>
+              <a:rPr lang="en-US" b="1" dirty="0"/>
+              <a:t>frontend &gt; app &gt; pages &gt; </a:t>
+            </a:r>
+            <a:r>
+              <a:rPr lang="en-US" b="1" dirty="0" err="1"/>
+              <a:t>index_solution.vue</a:t>
+            </a:r>
+            <a:br>
+              <a:rPr lang="en-US" b="1" dirty="0"/>
+            </a:br>
+            <a:r>
+              <a:rPr lang="en-US" b="1" dirty="0"/>
+              <a:t>                                on line 159</a:t>
+            </a:r>
+            <a:endParaRPr lang="en-001" b="1" dirty="0"/>
+          </a:p>
+        </p:txBody>
+      </p:sp>
+      <p:pic>
+        <p:nvPicPr>
+          <p:cNvPr id="4" name="Picture 3">
+            <a:extLst>
+              <a:ext uri="{FF2B5EF4-FFF2-40B4-BE49-F238E27FC236}">
+                <a16:creationId xmlns:a16="http://schemas.microsoft.com/office/drawing/2014/main" id="{8ED04584-560D-00F0-F6AE-333D57AD2939}"/>
+              </a:ext>
+            </a:extLst>
+          </p:cNvPr>
+          <p:cNvPicPr>
+            <a:picLocks noChangeAspect="1"/>
+          </p:cNvPicPr>
+          <p:nvPr/>
+        </p:nvPicPr>
+        <p:blipFill>
+          <a:blip r:embed="rId2"/>
+          <a:stretch>
+            <a:fillRect/>
+          </a:stretch>
+        </p:blipFill>
+        <p:spPr>
+          <a:xfrm>
+            <a:off x="8384599" y="0"/>
+            <a:ext cx="1132767" cy="1103768"/>
+          </a:xfrm>
+          <a:prstGeom prst="rect">
+            <a:avLst/>
+          </a:prstGeom>
+        </p:spPr>
+      </p:pic>
+      <p:pic>
+        <p:nvPicPr>
+          <p:cNvPr id="5" name="Picture 4">
+            <a:extLst>
+              <a:ext uri="{FF2B5EF4-FFF2-40B4-BE49-F238E27FC236}">
+                <a16:creationId xmlns:a16="http://schemas.microsoft.com/office/drawing/2014/main" id="{9BD0665F-B3C4-80ED-6A69-D54F435F056E}"/>
+              </a:ext>
+            </a:extLst>
+          </p:cNvPr>
+          <p:cNvPicPr>
+            <a:picLocks noChangeAspect="1"/>
+          </p:cNvPicPr>
+          <p:nvPr/>
+        </p:nvPicPr>
+        <p:blipFill>
+          <a:blip r:embed="rId3"/>
+          <a:stretch>
+            <a:fillRect/>
+          </a:stretch>
+        </p:blipFill>
+        <p:spPr>
+          <a:xfrm>
+            <a:off x="305871" y="2425464"/>
+            <a:ext cx="9446658" cy="4971926"/>
+          </a:xfrm>
+          <a:prstGeom prst="rect">
+            <a:avLst/>
+          </a:prstGeom>
+        </p:spPr>
+      </p:pic>
+      <p:sp>
+        <p:nvSpPr>
+          <p:cNvPr id="6" name="Rectangle 5">
+            <a:extLst>
+              <a:ext uri="{FF2B5EF4-FFF2-40B4-BE49-F238E27FC236}">
+                <a16:creationId xmlns:a16="http://schemas.microsoft.com/office/drawing/2014/main" id="{B9448FEA-8B91-DC9E-C566-31553ADA6EA2}"/>
+              </a:ext>
+            </a:extLst>
+          </p:cNvPr>
+          <p:cNvSpPr/>
+          <p:nvPr/>
+        </p:nvSpPr>
+        <p:spPr>
+          <a:xfrm>
+            <a:off x="2280862" y="4542841"/>
+            <a:ext cx="2599363" cy="1303155"/>
+          </a:xfrm>
+          <a:prstGeom prst="rect">
+            <a:avLst/>
+          </a:prstGeom>
+          <a:noFill/>
+          <a:ln w="9525" cap="flat" cmpd="sng" algn="ctr">
+            <a:solidFill>
+              <a:schemeClr val="accent4"/>
+            </a:solidFill>
+            <a:prstDash val="solid"/>
+            <a:round/>
+            <a:headEnd type="none" w="med" len="med"/>
+            <a:tailEnd type="none" w="med" len="med"/>
+          </a:ln>
+        </p:spPr>
+        <p:style>
+          <a:lnRef idx="0">
+            <a:scrgbClr r="0" g="0" b="0"/>
+          </a:lnRef>
+          <a:fillRef idx="0">
+            <a:scrgbClr r="0" g="0" b="0"/>
+          </a:fillRef>
+          <a:effectRef idx="0">
+            <a:scrgbClr r="0" g="0" b="0"/>
+          </a:effectRef>
+          <a:fontRef idx="minor">
+            <a:schemeClr val="accent4"/>
+          </a:fontRef>
+        </p:style>
+        <p:txBody>
+          <a:bodyPr rtlCol="0" anchor="ctr"/>
+          <a:lstStyle/>
+          <a:p>
+            <a:pPr algn="ctr"/>
+            <a:endParaRPr lang="en-001"/>
+          </a:p>
+        </p:txBody>
+      </p:sp>
+    </p:spTree>
+    <p:extLst>
+      <p:ext uri="{BB962C8B-B14F-4D97-AF65-F5344CB8AC3E}">
+        <p14:creationId xmlns:p14="http://schemas.microsoft.com/office/powerpoint/2010/main" val="2753748186"/>
       </p:ext>
     </p:extLst>
   </p:cSld>
@@ -28298,6 +29652,537 @@
         <p:cNvPr id="1" name="">
           <a:extLst>
             <a:ext uri="{FF2B5EF4-FFF2-40B4-BE49-F238E27FC236}">
+              <a16:creationId xmlns:a16="http://schemas.microsoft.com/office/drawing/2014/main" id="{17C45239-F511-5CFE-4589-D0F509323228}"/>
+            </a:ext>
+          </a:extLst>
+        </p:cNvPr>
+        <p:cNvGrpSpPr/>
+        <p:nvPr/>
+      </p:nvGrpSpPr>
+      <p:grpSpPr>
+        <a:xfrm>
+          <a:off x="0" y="0"/>
+          <a:ext cx="0" cy="0"/>
+          <a:chOff x="0" y="0"/>
+          <a:chExt cx="0" cy="0"/>
+        </a:xfrm>
+      </p:grpSpPr>
+      <p:sp>
+        <p:nvSpPr>
+          <p:cNvPr id="2" name="Title 1" hidden="1">
+            <a:extLst>
+              <a:ext uri="{FF2B5EF4-FFF2-40B4-BE49-F238E27FC236}">
+                <a16:creationId xmlns:a16="http://schemas.microsoft.com/office/drawing/2014/main" id="{A67948F5-1EBF-B51B-79D9-F4D212C3589A}"/>
+              </a:ext>
+            </a:extLst>
+          </p:cNvPr>
+          <p:cNvSpPr>
+            <a:spLocks noGrp="1"/>
+          </p:cNvSpPr>
+          <p:nvPr>
+            <p:ph type="title"/>
+          </p:nvPr>
+        </p:nvSpPr>
+        <p:spPr/>
+        <p:txBody>
+          <a:bodyPr/>
+          <a:lstStyle/>
+          <a:p>
+            <a:r>
+              <a:rPr lang="en-US" dirty="0"/>
+              <a:t>Cover Page</a:t>
+            </a:r>
+          </a:p>
+        </p:txBody>
+      </p:sp>
+      <p:sp>
+        <p:nvSpPr>
+          <p:cNvPr id="8" name="Title 1">
+            <a:extLst>
+              <a:ext uri="{FF2B5EF4-FFF2-40B4-BE49-F238E27FC236}">
+                <a16:creationId xmlns:a16="http://schemas.microsoft.com/office/drawing/2014/main" id="{926C7EC9-5777-CC1C-F717-43F4FF58CA01}"/>
+              </a:ext>
+            </a:extLst>
+          </p:cNvPr>
+          <p:cNvSpPr txBox="1">
+            <a:spLocks/>
+          </p:cNvSpPr>
+          <p:nvPr/>
+        </p:nvSpPr>
+        <p:spPr>
+          <a:xfrm>
+            <a:off x="2394781" y="376308"/>
+            <a:ext cx="5253486" cy="2564017"/>
+          </a:xfrm>
+          <a:prstGeom prst="rect">
+            <a:avLst/>
+          </a:prstGeom>
+        </p:spPr>
+        <p:txBody>
+          <a:bodyPr vert="horz" lIns="0" tIns="0" rIns="0" bIns="0" rtlCol="0" anchor="t">
+            <a:noAutofit/>
+          </a:bodyPr>
+          <a:lstStyle>
+            <a:lvl1pPr algn="ctr" defTabSz="754380" rtl="0" eaLnBrk="1" latinLnBrk="0" hangingPunct="1">
+              <a:lnSpc>
+                <a:spcPct val="90000"/>
+              </a:lnSpc>
+              <a:spcBef>
+                <a:spcPct val="0"/>
+              </a:spcBef>
+              <a:buNone/>
+              <a:defRPr sz="4000" kern="1200">
+                <a:solidFill>
+                  <a:schemeClr val="tx1"/>
+                </a:solidFill>
+                <a:latin typeface="+mj-lt"/>
+                <a:ea typeface="+mj-ea"/>
+                <a:cs typeface="+mj-cs"/>
+              </a:defRPr>
+            </a:lvl1pPr>
+          </a:lstStyle>
+          <a:p>
+            <a:pPr>
+              <a:lnSpc>
+                <a:spcPct val="75000"/>
+              </a:lnSpc>
+            </a:pPr>
+            <a:r>
+              <a:rPr lang="en-US" sz="6000" dirty="0">
+                <a:ln w="41275">
+                  <a:noFill/>
+                </a:ln>
+                <a:solidFill>
+                  <a:schemeClr val="accent2"/>
+                </a:solidFill>
+                <a:ea typeface="Source Sans Pro Black"/>
+              </a:rPr>
+              <a:t>Tools</a:t>
+            </a:r>
+          </a:p>
+          <a:p>
+            <a:pPr>
+              <a:lnSpc>
+                <a:spcPct val="75000"/>
+              </a:lnSpc>
+            </a:pPr>
+            <a:endParaRPr lang="en-US" sz="6000" dirty="0">
+              <a:ln w="41275">
+                <a:noFill/>
+              </a:ln>
+              <a:solidFill>
+                <a:schemeClr val="accent2"/>
+              </a:solidFill>
+              <a:ea typeface="Source Sans Pro Black"/>
+            </a:endParaRPr>
+          </a:p>
+        </p:txBody>
+      </p:sp>
+      <p:sp>
+        <p:nvSpPr>
+          <p:cNvPr id="32" name="TextBox 31">
+            <a:extLst>
+              <a:ext uri="{FF2B5EF4-FFF2-40B4-BE49-F238E27FC236}">
+                <a16:creationId xmlns:a16="http://schemas.microsoft.com/office/drawing/2014/main" id="{7322CCCE-279A-90CD-4685-30215060570D}"/>
+              </a:ext>
+            </a:extLst>
+          </p:cNvPr>
+          <p:cNvSpPr txBox="1"/>
+          <p:nvPr/>
+        </p:nvSpPr>
+        <p:spPr>
+          <a:xfrm>
+            <a:off x="2395248" y="1652683"/>
+            <a:ext cx="5257799" cy="1200329"/>
+          </a:xfrm>
+          <a:prstGeom prst="rect">
+            <a:avLst/>
+          </a:prstGeom>
+          <a:noFill/>
+        </p:spPr>
+        <p:txBody>
+          <a:bodyPr rot="0" spcFirstLastPara="0" vertOverflow="overflow" horzOverflow="overflow" vert="horz" wrap="square" lIns="91440" tIns="45720" rIns="91440" bIns="45720" numCol="1" spcCol="0" rtlCol="0" fromWordArt="0" anchor="t" anchorCtr="0" forceAA="0" compatLnSpc="1">
+            <a:prstTxWarp prst="textNoShape">
+              <a:avLst/>
+            </a:prstTxWarp>
+            <a:spAutoFit/>
+          </a:bodyPr>
+          <a:lstStyle/>
+          <a:p>
+            <a:pPr algn="ctr"/>
+            <a:br>
+              <a:rPr lang="en-GB" sz="3600" dirty="0">
+                <a:ea typeface="Source Sans Pro"/>
+              </a:rPr>
+            </a:br>
+            <a:endParaRPr lang="en-GB" sz="3600">
+              <a:solidFill>
+                <a:schemeClr val="bg2">
+                  <a:lumMod val="49000"/>
+                </a:schemeClr>
+              </a:solidFill>
+              <a:ea typeface="Source Sans Pro"/>
+            </a:endParaRPr>
+          </a:p>
+        </p:txBody>
+      </p:sp>
+      <p:cxnSp>
+        <p:nvCxnSpPr>
+          <p:cNvPr id="47" name="Straight Connector 46">
+            <a:extLst>
+              <a:ext uri="{FF2B5EF4-FFF2-40B4-BE49-F238E27FC236}">
+                <a16:creationId xmlns:a16="http://schemas.microsoft.com/office/drawing/2014/main" id="{D4D474ED-CC94-E747-3E63-B8E3A7B33C22}"/>
+              </a:ext>
+              <a:ext uri="{C183D7F6-B498-43B3-948B-1728B52AA6E4}">
+                <adec:decorative xmlns:adec="http://schemas.microsoft.com/office/drawing/2017/decorative" val="1"/>
+              </a:ext>
+            </a:extLst>
+          </p:cNvPr>
+          <p:cNvCxnSpPr>
+            <a:cxnSpLocks/>
+          </p:cNvCxnSpPr>
+          <p:nvPr/>
+        </p:nvCxnSpPr>
+        <p:spPr>
+          <a:xfrm>
+            <a:off x="687936" y="1712083"/>
+            <a:ext cx="8677751" cy="0"/>
+          </a:xfrm>
+          <a:prstGeom prst="line">
+            <a:avLst/>
+          </a:prstGeom>
+          <a:ln w="25400">
+            <a:solidFill>
+              <a:schemeClr val="accent2"/>
+            </a:solidFill>
+          </a:ln>
+        </p:spPr>
+        <p:style>
+          <a:lnRef idx="1">
+            <a:schemeClr val="accent1"/>
+          </a:lnRef>
+          <a:fillRef idx="0">
+            <a:schemeClr val="accent1"/>
+          </a:fillRef>
+          <a:effectRef idx="0">
+            <a:schemeClr val="accent1"/>
+          </a:effectRef>
+          <a:fontRef idx="minor">
+            <a:schemeClr val="tx1"/>
+          </a:fontRef>
+        </p:style>
+      </p:cxnSp>
+      <p:sp>
+        <p:nvSpPr>
+          <p:cNvPr id="42" name="TextBox 41">
+            <a:extLst>
+              <a:ext uri="{FF2B5EF4-FFF2-40B4-BE49-F238E27FC236}">
+                <a16:creationId xmlns:a16="http://schemas.microsoft.com/office/drawing/2014/main" id="{3AB5FAE8-8CA0-182F-316F-7B25B62778C1}"/>
+              </a:ext>
+            </a:extLst>
+          </p:cNvPr>
+          <p:cNvSpPr txBox="1"/>
+          <p:nvPr/>
+        </p:nvSpPr>
+        <p:spPr>
+          <a:xfrm>
+            <a:off x="825979" y="2334065"/>
+            <a:ext cx="8410488" cy="3416320"/>
+          </a:xfrm>
+          <a:prstGeom prst="rect">
+            <a:avLst/>
+          </a:prstGeom>
+          <a:ln>
+            <a:noFill/>
+          </a:ln>
+        </p:spPr>
+        <p:style>
+          <a:lnRef idx="2">
+            <a:schemeClr val="accent2"/>
+          </a:lnRef>
+          <a:fillRef idx="1">
+            <a:schemeClr val="lt1"/>
+          </a:fillRef>
+          <a:effectRef idx="0">
+            <a:schemeClr val="accent2"/>
+          </a:effectRef>
+          <a:fontRef idx="minor">
+            <a:schemeClr val="dk1"/>
+          </a:fontRef>
+        </p:style>
+        <p:txBody>
+          <a:bodyPr rot="0" spcFirstLastPara="0" vertOverflow="overflow" horzOverflow="overflow" vert="horz" wrap="square" lIns="91440" tIns="45720" rIns="91440" bIns="45720" numCol="1" spcCol="0" rtlCol="0" fromWordArt="0" anchor="t" anchorCtr="0" forceAA="0" compatLnSpc="1">
+            <a:prstTxWarp prst="textNoShape">
+              <a:avLst/>
+            </a:prstTxWarp>
+            <a:spAutoFit/>
+          </a:bodyPr>
+          <a:lstStyle/>
+          <a:p>
+            <a:pPr marL="457200" indent="-457200">
+              <a:buFont typeface="+mj-lt"/>
+              <a:buAutoNum type="arabicPeriod"/>
+            </a:pPr>
+            <a:r>
+              <a:rPr lang="en-GB" sz="2400" b="1" dirty="0">
+                <a:ea typeface="Source Sans Pro"/>
+              </a:rPr>
+              <a:t>You’ve started your backend server </a:t>
+            </a:r>
+            <a:br>
+              <a:rPr lang="en-GB" sz="2400" b="1" dirty="0">
+                <a:ea typeface="Source Sans Pro"/>
+              </a:rPr>
+            </a:br>
+            <a:r>
+              <a:rPr lang="en-GB" sz="2400" b="1" dirty="0">
+                <a:ea typeface="Source Sans Pro"/>
+              </a:rPr>
+              <a:t>`</a:t>
+            </a:r>
+            <a:r>
+              <a:rPr lang="en-GB" sz="2400" b="1" dirty="0" err="1">
+                <a:solidFill>
+                  <a:schemeClr val="tx1">
+                    <a:lumMod val="50000"/>
+                    <a:lumOff val="50000"/>
+                  </a:schemeClr>
+                </a:solidFill>
+                <a:ea typeface="Source Sans Pro"/>
+              </a:rPr>
+              <a:t>uv</a:t>
+            </a:r>
+            <a:r>
+              <a:rPr lang="en-GB" sz="2400" b="1" dirty="0">
+                <a:solidFill>
+                  <a:schemeClr val="tx1">
+                    <a:lumMod val="50000"/>
+                    <a:lumOff val="50000"/>
+                  </a:schemeClr>
+                </a:solidFill>
+                <a:ea typeface="Source Sans Pro"/>
+              </a:rPr>
+              <a:t> run python manage.py </a:t>
+            </a:r>
+            <a:r>
+              <a:rPr lang="en-GB" sz="2400" b="1" dirty="0" err="1">
+                <a:solidFill>
+                  <a:schemeClr val="tx1">
+                    <a:lumMod val="50000"/>
+                    <a:lumOff val="50000"/>
+                  </a:schemeClr>
+                </a:solidFill>
+                <a:ea typeface="Source Sans Pro"/>
+              </a:rPr>
+              <a:t>runserver</a:t>
+            </a:r>
+            <a:r>
+              <a:rPr lang="en-GB" sz="2400" b="1" dirty="0">
+                <a:ea typeface="Source Sans Pro"/>
+              </a:rPr>
+              <a:t>`</a:t>
+            </a:r>
+          </a:p>
+          <a:p>
+            <a:pPr marL="457200" indent="-457200">
+              <a:buFont typeface="+mj-lt"/>
+              <a:buAutoNum type="arabicPeriod"/>
+            </a:pPr>
+            <a:r>
+              <a:rPr lang="en-GB" sz="2400" b="1" dirty="0">
+                <a:ea typeface="Source Sans Pro"/>
+              </a:rPr>
+              <a:t>You’ve started your frontend server </a:t>
+            </a:r>
+            <a:br>
+              <a:rPr lang="en-GB" sz="2400" b="1" dirty="0">
+                <a:ea typeface="Source Sans Pro"/>
+              </a:rPr>
+            </a:br>
+            <a:r>
+              <a:rPr lang="en-GB" sz="2400" b="1" dirty="0">
+                <a:ea typeface="Source Sans Pro"/>
+              </a:rPr>
+              <a:t>`</a:t>
+            </a:r>
+            <a:r>
+              <a:rPr lang="en-GB" sz="2400" b="1" dirty="0">
+                <a:solidFill>
+                  <a:schemeClr val="tx1">
+                    <a:lumMod val="50000"/>
+                    <a:lumOff val="50000"/>
+                  </a:schemeClr>
+                </a:solidFill>
+                <a:ea typeface="Source Sans Pro"/>
+              </a:rPr>
+              <a:t>bun run dev</a:t>
+            </a:r>
+            <a:r>
+              <a:rPr lang="en-GB" sz="2400" b="1" dirty="0">
+                <a:ea typeface="Source Sans Pro"/>
+              </a:rPr>
+              <a:t>`</a:t>
+            </a:r>
+          </a:p>
+          <a:p>
+            <a:pPr marL="457200" indent="-457200">
+              <a:buFont typeface="+mj-lt"/>
+              <a:buAutoNum type="arabicPeriod"/>
+            </a:pPr>
+            <a:r>
+              <a:rPr lang="en-GB" sz="2400" b="1" dirty="0">
+                <a:ea typeface="Source Sans Pro"/>
+              </a:rPr>
+              <a:t>You’ve started loading the frontend `</a:t>
+            </a:r>
+            <a:r>
+              <a:rPr lang="en-GB" sz="2400" b="1" dirty="0">
+                <a:solidFill>
+                  <a:schemeClr val="tx1">
+                    <a:lumMod val="50000"/>
+                    <a:lumOff val="50000"/>
+                  </a:schemeClr>
+                </a:solidFill>
+                <a:ea typeface="Source Sans Pro"/>
+              </a:rPr>
+              <a:t>http://localhost:3000</a:t>
+            </a:r>
+            <a:r>
+              <a:rPr lang="en-GB" sz="2400" b="1" dirty="0">
+                <a:ea typeface="Source Sans Pro"/>
+              </a:rPr>
+              <a:t>`</a:t>
+            </a:r>
+          </a:p>
+          <a:p>
+            <a:pPr marL="457200" indent="-457200">
+              <a:buFont typeface="+mj-lt"/>
+              <a:buAutoNum type="arabicPeriod"/>
+            </a:pPr>
+            <a:r>
+              <a:rPr lang="en-GB" sz="2400" b="1" dirty="0">
+                <a:ea typeface="Source Sans Pro"/>
+              </a:rPr>
+              <a:t>You’ve started loading the backend `</a:t>
+            </a:r>
+            <a:r>
+              <a:rPr lang="en-GB" sz="2400" b="1" dirty="0">
+                <a:solidFill>
+                  <a:schemeClr val="tx1">
+                    <a:lumMod val="50000"/>
+                    <a:lumOff val="50000"/>
+                  </a:schemeClr>
+                </a:solidFill>
+                <a:ea typeface="Source Sans Pro"/>
+              </a:rPr>
+              <a:t>http://127.0.0.1:8000/</a:t>
+            </a:r>
+            <a:r>
+              <a:rPr lang="en-GB" sz="2400" b="1" dirty="0" err="1">
+                <a:solidFill>
+                  <a:schemeClr val="tx1">
+                    <a:lumMod val="50000"/>
+                    <a:lumOff val="50000"/>
+                  </a:schemeClr>
+                </a:solidFill>
+                <a:ea typeface="Source Sans Pro"/>
+              </a:rPr>
+              <a:t>api</a:t>
+            </a:r>
+            <a:r>
+              <a:rPr lang="en-GB" sz="2400" b="1" dirty="0">
+                <a:solidFill>
+                  <a:schemeClr val="tx1">
+                    <a:lumMod val="50000"/>
+                    <a:lumOff val="50000"/>
+                  </a:schemeClr>
+                </a:solidFill>
+                <a:ea typeface="Source Sans Pro"/>
+              </a:rPr>
+              <a:t>/docs</a:t>
+            </a:r>
+            <a:r>
+              <a:rPr lang="en-GB" sz="2400" b="1" dirty="0">
+                <a:ea typeface="Source Sans Pro"/>
+              </a:rPr>
+              <a:t>`</a:t>
+            </a:r>
+          </a:p>
+          <a:p>
+            <a:pPr marL="342900" indent="-342900">
+              <a:buFont typeface="Arial" panose="020B0604020202020204" pitchFamily="34" charset="0"/>
+              <a:buChar char="•"/>
+            </a:pPr>
+            <a:endParaRPr lang="en-GB" sz="2400" b="1" dirty="0">
+              <a:ea typeface="Source Sans Pro"/>
+            </a:endParaRPr>
+          </a:p>
+        </p:txBody>
+      </p:sp>
+      <p:pic>
+        <p:nvPicPr>
+          <p:cNvPr id="4" name="Graphic 3" descr="robot to color">
+            <a:extLst>
+              <a:ext uri="{FF2B5EF4-FFF2-40B4-BE49-F238E27FC236}">
+                <a16:creationId xmlns:a16="http://schemas.microsoft.com/office/drawing/2014/main" id="{4246EEBE-EA7D-2239-CB94-12E2A7E150D3}"/>
+              </a:ext>
+            </a:extLst>
+          </p:cNvPr>
+          <p:cNvPicPr>
+            <a:picLocks noChangeAspect="1"/>
+          </p:cNvPicPr>
+          <p:nvPr/>
+        </p:nvPicPr>
+        <p:blipFill rotWithShape="1">
+          <a:blip>
+            <a:extLst>
+              <a:ext uri="{96DAC541-7B7A-43D3-8B79-37D633B846F1}">
+                <asvg:svgBlip xmlns:asvg="http://schemas.microsoft.com/office/drawing/2016/SVG/main" r:embed="rId2"/>
+              </a:ext>
+            </a:extLst>
+          </a:blip>
+          <a:srcRect l="21731" r="19568"/>
+          <a:stretch/>
+        </p:blipFill>
+        <p:spPr>
+          <a:xfrm rot="10800000">
+            <a:off x="3273322" y="119475"/>
+            <a:ext cx="1161689" cy="1790042"/>
+          </a:xfrm>
+          <a:prstGeom prst="rect">
+            <a:avLst/>
+          </a:prstGeom>
+        </p:spPr>
+      </p:pic>
+    </p:spTree>
+    <p:extLst>
+      <p:ext uri="{BB962C8B-B14F-4D97-AF65-F5344CB8AC3E}">
+        <p14:creationId xmlns:p14="http://schemas.microsoft.com/office/powerpoint/2010/main" val="218191877"/>
+      </p:ext>
+    </p:extLst>
+  </p:cSld>
+  <p:clrMapOvr>
+    <a:masterClrMapping/>
+  </p:clrMapOvr>
+</p:sld>
+</file>
+
+<file path=ppt/slides/slide7.xml><?xml version="1.0" encoding="utf-8"?>
+<p:sld xmlns:a="http://schemas.openxmlformats.org/drawingml/2006/main" xmlns:r="http://schemas.openxmlformats.org/officeDocument/2006/relationships" xmlns:p="http://schemas.openxmlformats.org/presentationml/2006/main">
+  <p:cSld>
+    <p:bg>
+      <p:bgPr>
+        <a:solidFill>
+          <a:schemeClr val="bg1"/>
+        </a:solidFill>
+        <a:effectLst/>
+      </p:bgPr>
+    </p:bg>
+    <p:spTree>
+      <p:nvGrpSpPr>
+        <p:cNvPr id="1" name="">
+          <a:extLst>
+            <a:ext uri="{FF2B5EF4-FFF2-40B4-BE49-F238E27FC236}">
               <a16:creationId xmlns:a16="http://schemas.microsoft.com/office/drawing/2014/main" id="{47A76F1A-0EFC-A652-5FB9-17A7C5F3B0D0}"/>
             </a:ext>
           </a:extLst>
@@ -32356,7 +34241,7 @@
 </p:sld>
 </file>
 
-<file path=ppt/slides/slide7.xml><?xml version="1.0" encoding="utf-8"?>
+<file path=ppt/slides/slide8.xml><?xml version="1.0" encoding="utf-8"?>
 <p:sld xmlns:a="http://schemas.openxmlformats.org/drawingml/2006/main" xmlns:r="http://schemas.openxmlformats.org/officeDocument/2006/relationships" xmlns:p="http://schemas.openxmlformats.org/presentationml/2006/main">
   <p:cSld>
     <p:bg>
@@ -32892,7 +34777,7 @@
 </p:sld>
 </file>
 
-<file path=ppt/slides/slide8.xml><?xml version="1.0" encoding="utf-8"?>
+<file path=ppt/slides/slide9.xml><?xml version="1.0" encoding="utf-8"?>
 <p:sld xmlns:a="http://schemas.openxmlformats.org/drawingml/2006/main" xmlns:r="http://schemas.openxmlformats.org/officeDocument/2006/relationships" xmlns:p="http://schemas.openxmlformats.org/presentationml/2006/main">
   <p:cSld>
     <p:bg>
@@ -33443,584 +35328,6 @@
     <p:extLst>
       <p:ext uri="{BB962C8B-B14F-4D97-AF65-F5344CB8AC3E}">
         <p14:creationId xmlns:p14="http://schemas.microsoft.com/office/powerpoint/2010/main" val="997040705"/>
-      </p:ext>
-    </p:extLst>
-  </p:cSld>
-  <p:clrMapOvr>
-    <a:masterClrMapping/>
-  </p:clrMapOvr>
-</p:sld>
-</file>
-
-<file path=ppt/slides/slide9.xml><?xml version="1.0" encoding="utf-8"?>
-<p:sld xmlns:a="http://schemas.openxmlformats.org/drawingml/2006/main" xmlns:r="http://schemas.openxmlformats.org/officeDocument/2006/relationships" xmlns:p="http://schemas.openxmlformats.org/presentationml/2006/main">
-  <p:cSld>
-    <p:bg>
-      <p:bgPr>
-        <a:solidFill>
-          <a:schemeClr val="bg1"/>
-        </a:solidFill>
-        <a:effectLst/>
-      </p:bgPr>
-    </p:bg>
-    <p:spTree>
-      <p:nvGrpSpPr>
-        <p:cNvPr id="1" name="">
-          <a:extLst>
-            <a:ext uri="{FF2B5EF4-FFF2-40B4-BE49-F238E27FC236}">
-              <a16:creationId xmlns:a16="http://schemas.microsoft.com/office/drawing/2014/main" id="{3620E0B4-EF70-230E-FE50-7B9FF95E94EE}"/>
-            </a:ext>
-          </a:extLst>
-        </p:cNvPr>
-        <p:cNvGrpSpPr/>
-        <p:nvPr/>
-      </p:nvGrpSpPr>
-      <p:grpSpPr>
-        <a:xfrm>
-          <a:off x="0" y="0"/>
-          <a:ext cx="0" cy="0"/>
-          <a:chOff x="0" y="0"/>
-          <a:chExt cx="0" cy="0"/>
-        </a:xfrm>
-      </p:grpSpPr>
-      <p:sp>
-        <p:nvSpPr>
-          <p:cNvPr id="2" name="Title 1" hidden="1">
-            <a:extLst>
-              <a:ext uri="{FF2B5EF4-FFF2-40B4-BE49-F238E27FC236}">
-                <a16:creationId xmlns:a16="http://schemas.microsoft.com/office/drawing/2014/main" id="{582F56C0-4B4F-4445-7D2D-69CC65646A61}"/>
-              </a:ext>
-            </a:extLst>
-          </p:cNvPr>
-          <p:cNvSpPr>
-            <a:spLocks noGrp="1"/>
-          </p:cNvSpPr>
-          <p:nvPr>
-            <p:ph type="title"/>
-          </p:nvPr>
-        </p:nvSpPr>
-        <p:spPr/>
-        <p:txBody>
-          <a:bodyPr/>
-          <a:lstStyle/>
-          <a:p>
-            <a:r>
-              <a:rPr lang="en-US" dirty="0"/>
-              <a:t>Cover Page</a:t>
-            </a:r>
-          </a:p>
-        </p:txBody>
-      </p:sp>
-      <p:sp>
-        <p:nvSpPr>
-          <p:cNvPr id="8" name="Title 1">
-            <a:extLst>
-              <a:ext uri="{FF2B5EF4-FFF2-40B4-BE49-F238E27FC236}">
-                <a16:creationId xmlns:a16="http://schemas.microsoft.com/office/drawing/2014/main" id="{CC281F5C-A967-F0BE-F681-D41DC883BFF6}"/>
-              </a:ext>
-            </a:extLst>
-          </p:cNvPr>
-          <p:cNvSpPr txBox="1">
-            <a:spLocks/>
-          </p:cNvSpPr>
-          <p:nvPr/>
-        </p:nvSpPr>
-        <p:spPr>
-          <a:xfrm>
-            <a:off x="2403752" y="399811"/>
-            <a:ext cx="5253486" cy="719719"/>
-          </a:xfrm>
-          <a:prstGeom prst="rect">
-            <a:avLst/>
-          </a:prstGeom>
-        </p:spPr>
-        <p:txBody>
-          <a:bodyPr vert="horz" lIns="0" tIns="0" rIns="0" bIns="0" rtlCol="0" anchor="t">
-            <a:noAutofit/>
-          </a:bodyPr>
-          <a:lstStyle>
-            <a:lvl1pPr algn="ctr" defTabSz="754380" rtl="0" eaLnBrk="1" latinLnBrk="0" hangingPunct="1">
-              <a:lnSpc>
-                <a:spcPct val="90000"/>
-              </a:lnSpc>
-              <a:spcBef>
-                <a:spcPct val="0"/>
-              </a:spcBef>
-              <a:buNone/>
-              <a:defRPr sz="4000" kern="1200">
-                <a:solidFill>
-                  <a:schemeClr val="tx1"/>
-                </a:solidFill>
-                <a:latin typeface="+mj-lt"/>
-                <a:ea typeface="+mj-ea"/>
-                <a:cs typeface="+mj-cs"/>
-              </a:defRPr>
-            </a:lvl1pPr>
-          </a:lstStyle>
-          <a:p>
-            <a:pPr>
-              <a:lnSpc>
-                <a:spcPct val="75000"/>
-              </a:lnSpc>
-            </a:pPr>
-            <a:r>
-              <a:rPr lang="en-US" sz="6000" u="sng" dirty="0" err="1">
-                <a:ln w="41275">
-                  <a:noFill/>
-                </a:ln>
-                <a:solidFill>
-                  <a:schemeClr val="accent2"/>
-                </a:solidFill>
-                <a:ea typeface="Source Sans Pro Black"/>
-              </a:rPr>
-              <a:t>Gitflow</a:t>
-            </a:r>
-            <a:endParaRPr lang="en-US" u="sng" dirty="0" err="1">
-              <a:solidFill>
-                <a:schemeClr val="accent2"/>
-              </a:solidFill>
-            </a:endParaRPr>
-          </a:p>
-          <a:p>
-            <a:pPr>
-              <a:lnSpc>
-                <a:spcPct val="75000"/>
-              </a:lnSpc>
-            </a:pPr>
-            <a:r>
-              <a:rPr lang="en-US" sz="3200">
-                <a:ln w="41275">
-                  <a:noFill/>
-                </a:ln>
-                <a:solidFill>
-                  <a:schemeClr val="tx1">
-                    <a:lumMod val="76000"/>
-                    <a:lumOff val="24000"/>
-                  </a:schemeClr>
-                </a:solidFill>
-                <a:ea typeface="Source Sans Pro Black"/>
-              </a:rPr>
-              <a:t>Git Workflows</a:t>
-            </a:r>
-            <a:endParaRPr lang="en-US" sz="3200" u="sng" dirty="0">
-              <a:ln w="41275">
-                <a:noFill/>
-              </a:ln>
-              <a:solidFill>
-                <a:schemeClr val="tx1">
-                  <a:lumMod val="76000"/>
-                  <a:lumOff val="24000"/>
-                </a:schemeClr>
-              </a:solidFill>
-              <a:ea typeface="Source Sans Pro Black"/>
-            </a:endParaRPr>
-          </a:p>
-        </p:txBody>
-      </p:sp>
-      <p:sp>
-        <p:nvSpPr>
-          <p:cNvPr id="32" name="TextBox 31">
-            <a:extLst>
-              <a:ext uri="{FF2B5EF4-FFF2-40B4-BE49-F238E27FC236}">
-                <a16:creationId xmlns:a16="http://schemas.microsoft.com/office/drawing/2014/main" id="{B5712A2E-1781-225E-238D-5E6E3E3CEA5B}"/>
-              </a:ext>
-            </a:extLst>
-          </p:cNvPr>
-          <p:cNvSpPr txBox="1"/>
-          <p:nvPr/>
-        </p:nvSpPr>
-        <p:spPr>
-          <a:xfrm>
-            <a:off x="2395248" y="1652683"/>
-            <a:ext cx="5257799" cy="1200329"/>
-          </a:xfrm>
-          <a:prstGeom prst="rect">
-            <a:avLst/>
-          </a:prstGeom>
-          <a:noFill/>
-        </p:spPr>
-        <p:txBody>
-          <a:bodyPr rot="0" spcFirstLastPara="0" vertOverflow="overflow" horzOverflow="overflow" vert="horz" wrap="square" lIns="91440" tIns="45720" rIns="91440" bIns="45720" numCol="1" spcCol="0" rtlCol="0" fromWordArt="0" anchor="t" anchorCtr="0" forceAA="0" compatLnSpc="1">
-            <a:prstTxWarp prst="textNoShape">
-              <a:avLst/>
-            </a:prstTxWarp>
-            <a:spAutoFit/>
-          </a:bodyPr>
-          <a:lstStyle/>
-          <a:p>
-            <a:pPr algn="ctr"/>
-            <a:br>
-              <a:rPr lang="en-GB" sz="3600" dirty="0">
-                <a:ea typeface="Source Sans Pro"/>
-              </a:rPr>
-            </a:br>
-            <a:endParaRPr lang="en-GB" sz="3600">
-              <a:solidFill>
-                <a:schemeClr val="bg2">
-                  <a:lumMod val="49000"/>
-                </a:schemeClr>
-              </a:solidFill>
-              <a:ea typeface="Source Sans Pro"/>
-            </a:endParaRPr>
-          </a:p>
-        </p:txBody>
-      </p:sp>
-      <p:cxnSp>
-        <p:nvCxnSpPr>
-          <p:cNvPr id="47" name="Straight Connector 46">
-            <a:extLst>
-              <a:ext uri="{FF2B5EF4-FFF2-40B4-BE49-F238E27FC236}">
-                <a16:creationId xmlns:a16="http://schemas.microsoft.com/office/drawing/2014/main" id="{17CE5083-F6E9-18C8-284B-F1C4AF5FA3D9}"/>
-              </a:ext>
-              <a:ext uri="{C183D7F6-B498-43B3-948B-1728B52AA6E4}">
-                <adec:decorative xmlns:adec="http://schemas.microsoft.com/office/drawing/2017/decorative" val="1"/>
-              </a:ext>
-            </a:extLst>
-          </p:cNvPr>
-          <p:cNvCxnSpPr>
-            <a:cxnSpLocks/>
-          </p:cNvCxnSpPr>
-          <p:nvPr/>
-        </p:nvCxnSpPr>
-        <p:spPr>
-          <a:xfrm>
-            <a:off x="929926" y="1880443"/>
-            <a:ext cx="8677751" cy="0"/>
-          </a:xfrm>
-          <a:prstGeom prst="line">
-            <a:avLst/>
-          </a:prstGeom>
-          <a:ln w="25400">
-            <a:solidFill>
-              <a:schemeClr val="accent2"/>
-            </a:solidFill>
-          </a:ln>
-        </p:spPr>
-        <p:style>
-          <a:lnRef idx="1">
-            <a:schemeClr val="accent1"/>
-          </a:lnRef>
-          <a:fillRef idx="0">
-            <a:schemeClr val="accent1"/>
-          </a:fillRef>
-          <a:effectRef idx="0">
-            <a:schemeClr val="accent1"/>
-          </a:effectRef>
-          <a:fontRef idx="minor">
-            <a:schemeClr val="tx1"/>
-          </a:fontRef>
-        </p:style>
-      </p:cxnSp>
-      <p:pic>
-        <p:nvPicPr>
-          <p:cNvPr id="5" name="Graphic 4" descr="Hotfix branch within git workflow">
-            <a:extLst>
-              <a:ext uri="{FF2B5EF4-FFF2-40B4-BE49-F238E27FC236}">
-                <a16:creationId xmlns:a16="http://schemas.microsoft.com/office/drawing/2014/main" id="{23673354-41CF-DB5D-738E-24739AB056FB}"/>
-              </a:ext>
-            </a:extLst>
-          </p:cNvPr>
-          <p:cNvPicPr>
-            <a:picLocks noChangeAspect="1"/>
-          </p:cNvPicPr>
-          <p:nvPr/>
-        </p:nvPicPr>
-        <p:blipFill>
-          <a:blip>
-            <a:extLst>
-              <a:ext uri="{96DAC541-7B7A-43D3-8B79-37D633B846F1}">
-                <asvg:svgBlip xmlns:asvg="http://schemas.microsoft.com/office/drawing/2016/SVG/main" r:embed="rId2"/>
-              </a:ext>
-            </a:extLst>
-          </a:blip>
-          <a:stretch>
-            <a:fillRect/>
-          </a:stretch>
-        </p:blipFill>
-        <p:spPr>
-          <a:xfrm>
-            <a:off x="2875578" y="2052123"/>
-            <a:ext cx="6808252" cy="4864661"/>
-          </a:xfrm>
-          <a:prstGeom prst="rect">
-            <a:avLst/>
-          </a:prstGeom>
-        </p:spPr>
-      </p:pic>
-      <p:pic>
-        <p:nvPicPr>
-          <p:cNvPr id="3" name="Picture 2" descr="A cartoon character with a computer&#10;&#10;AI-generated content may be incorrect.">
-            <a:extLst>
-              <a:ext uri="{FF2B5EF4-FFF2-40B4-BE49-F238E27FC236}">
-                <a16:creationId xmlns:a16="http://schemas.microsoft.com/office/drawing/2014/main" id="{21BCB5C4-433E-CBE4-7FE7-7773102DA8C7}"/>
-              </a:ext>
-            </a:extLst>
-          </p:cNvPr>
-          <p:cNvPicPr>
-            <a:picLocks noChangeAspect="1"/>
-          </p:cNvPicPr>
-          <p:nvPr/>
-        </p:nvPicPr>
-        <p:blipFill>
-          <a:blip r:embed="rId3"/>
-          <a:stretch>
-            <a:fillRect/>
-          </a:stretch>
-        </p:blipFill>
-        <p:spPr>
-          <a:xfrm rot="360000">
-            <a:off x="2075205" y="59612"/>
-            <a:ext cx="1595041" cy="1509430"/>
-          </a:xfrm>
-          <a:prstGeom prst="rect">
-            <a:avLst/>
-          </a:prstGeom>
-          <a:ln>
-            <a:noFill/>
-          </a:ln>
-          <a:effectLst>
-            <a:softEdge rad="112500"/>
-          </a:effectLst>
-        </p:spPr>
-      </p:pic>
-      <p:sp>
-        <p:nvSpPr>
-          <p:cNvPr id="4" name="TextBox 3">
-            <a:extLst>
-              <a:ext uri="{FF2B5EF4-FFF2-40B4-BE49-F238E27FC236}">
-                <a16:creationId xmlns:a16="http://schemas.microsoft.com/office/drawing/2014/main" id="{29EA55F1-5084-6A30-566B-F1583FF7DA2E}"/>
-              </a:ext>
-            </a:extLst>
-          </p:cNvPr>
-          <p:cNvSpPr txBox="1"/>
-          <p:nvPr/>
-        </p:nvSpPr>
-        <p:spPr>
-          <a:xfrm>
-            <a:off x="130679" y="3232340"/>
-            <a:ext cx="2743199" cy="1938992"/>
-          </a:xfrm>
-          <a:prstGeom prst="rect">
-            <a:avLst/>
-          </a:prstGeom>
-          <a:noFill/>
-        </p:spPr>
-        <p:txBody>
-          <a:bodyPr rot="0" spcFirstLastPara="0" vertOverflow="overflow" horzOverflow="overflow" vert="horz" wrap="square" lIns="91440" tIns="45720" rIns="91440" bIns="45720" numCol="1" spcCol="0" rtlCol="0" fromWordArt="0" anchor="t" anchorCtr="0" forceAA="0" compatLnSpc="1">
-            <a:prstTxWarp prst="textNoShape">
-              <a:avLst/>
-            </a:prstTxWarp>
-            <a:spAutoFit/>
-          </a:bodyPr>
-          <a:lstStyle/>
-          <a:p>
-            <a:r>
-              <a:rPr lang="en-GB" sz="2000" b="1">
-                <a:ea typeface="Source Sans Pro"/>
-              </a:rPr>
-              <a:t>Examples of branches:</a:t>
-            </a:r>
-            <a:endParaRPr lang="en-US" b="1"/>
-          </a:p>
-          <a:p>
-            <a:pPr marL="342900" indent="-342900">
-              <a:buFont typeface="Wingdings"/>
-              <a:buChar char="ü"/>
-            </a:pPr>
-            <a:r>
-              <a:rPr lang="en-GB" sz="2000" b="1">
-                <a:ea typeface="Source Sans Pro"/>
-              </a:rPr>
-              <a:t>main</a:t>
-            </a:r>
-            <a:endParaRPr lang="en-GB" sz="2000" dirty="0">
-              <a:ea typeface="Source Sans Pro"/>
-            </a:endParaRPr>
-          </a:p>
-          <a:p>
-            <a:pPr marL="342900" indent="-342900">
-              <a:buFont typeface="Wingdings"/>
-              <a:buChar char="ü"/>
-            </a:pPr>
-            <a:r>
-              <a:rPr lang="en-GB" sz="2000" b="1">
-                <a:ea typeface="Source Sans Pro"/>
-              </a:rPr>
-              <a:t>develop</a:t>
-            </a:r>
-            <a:endParaRPr lang="en-GB" sz="2000" dirty="0">
-              <a:ea typeface="Source Sans Pro"/>
-            </a:endParaRPr>
-          </a:p>
-          <a:p>
-            <a:pPr marL="342900" indent="-342900">
-              <a:buFont typeface="Wingdings"/>
-              <a:buChar char="ü"/>
-            </a:pPr>
-            <a:r>
-              <a:rPr lang="en-GB" sz="2000" b="1">
-                <a:ea typeface="Source Sans Pro"/>
-              </a:rPr>
-              <a:t>hotfix</a:t>
-            </a:r>
-            <a:r>
-              <a:rPr lang="en-GB" sz="2000">
-                <a:ea typeface="Source Sans Pro"/>
-              </a:rPr>
-              <a:t>/page-crash</a:t>
-            </a:r>
-          </a:p>
-          <a:p>
-            <a:pPr marL="342900" indent="-342900">
-              <a:buFont typeface="Wingdings"/>
-              <a:buChar char="ü"/>
-            </a:pPr>
-            <a:r>
-              <a:rPr lang="en-GB" sz="2000" b="1">
-                <a:ea typeface="Source Sans Pro"/>
-              </a:rPr>
-              <a:t>release</a:t>
-            </a:r>
-            <a:r>
-              <a:rPr lang="en-GB" sz="2000">
-                <a:ea typeface="Source Sans Pro"/>
-              </a:rPr>
-              <a:t>/1.0.0</a:t>
-            </a:r>
-          </a:p>
-          <a:p>
-            <a:pPr marL="342900" indent="-342900">
-              <a:buFont typeface="Wingdings"/>
-              <a:buChar char="ü"/>
-            </a:pPr>
-            <a:r>
-              <a:rPr lang="en-GB" sz="2000" b="1" dirty="0">
-                <a:ea typeface="Source Sans Pro"/>
-              </a:rPr>
-              <a:t>feature</a:t>
-            </a:r>
-            <a:r>
-              <a:rPr lang="en-GB" sz="2000" dirty="0">
-                <a:ea typeface="Source Sans Pro"/>
-              </a:rPr>
-              <a:t>/</a:t>
-            </a:r>
-            <a:r>
-              <a:rPr lang="en-GB" sz="2000" dirty="0" err="1">
-                <a:ea typeface="Source Sans Pro"/>
-              </a:rPr>
-              <a:t>todo</a:t>
-            </a:r>
-            <a:r>
-              <a:rPr lang="en-GB" sz="2000" dirty="0">
-                <a:ea typeface="Source Sans Pro"/>
-              </a:rPr>
-              <a:t>-page</a:t>
-            </a:r>
-          </a:p>
-        </p:txBody>
-      </p:sp>
-      <p:sp>
-        <p:nvSpPr>
-          <p:cNvPr id="6" name="TextBox 5">
-            <a:extLst>
-              <a:ext uri="{FF2B5EF4-FFF2-40B4-BE49-F238E27FC236}">
-                <a16:creationId xmlns:a16="http://schemas.microsoft.com/office/drawing/2014/main" id="{E3B2EB25-E3AE-77E3-8923-7FACD0D1D8FA}"/>
-              </a:ext>
-            </a:extLst>
-          </p:cNvPr>
-          <p:cNvSpPr txBox="1"/>
-          <p:nvPr/>
-        </p:nvSpPr>
-        <p:spPr>
-          <a:xfrm>
-            <a:off x="638421" y="7001411"/>
-            <a:ext cx="8791979" cy="1222642"/>
-          </a:xfrm>
-          <a:prstGeom prst="rect">
-            <a:avLst/>
-          </a:prstGeom>
-          <a:noFill/>
-        </p:spPr>
-        <p:txBody>
-          <a:bodyPr rot="0" spcFirstLastPara="0" vertOverflow="overflow" horzOverflow="overflow" vert="horz" wrap="square" lIns="91440" tIns="45720" rIns="91440" bIns="45720" numCol="1" spcCol="0" rtlCol="0" fromWordArt="0" anchor="t" anchorCtr="0" forceAA="0" compatLnSpc="1">
-            <a:prstTxWarp prst="textNoShape">
-              <a:avLst/>
-            </a:prstTxWarp>
-            <a:spAutoFit/>
-          </a:bodyPr>
-          <a:lstStyle/>
-          <a:p>
-            <a:pPr rtl="0">
-              <a:lnSpc>
-                <a:spcPts val="2025"/>
-              </a:lnSpc>
-            </a:pPr>
-            <a:r>
-              <a:rPr lang="en-GB" sz="2000" baseline="0">
-                <a:latin typeface="Source Sans Pro"/>
-                <a:ea typeface="Segoe UI"/>
-                <a:cs typeface="Segoe UI"/>
-              </a:rPr>
-              <a:t>Document reference:</a:t>
-            </a:r>
-            <a:r>
-              <a:rPr lang="en-GB" sz="2000">
-                <a:latin typeface="Source Sans Pro"/>
-                <a:ea typeface="Segoe UI"/>
-                <a:cs typeface="Segoe UI"/>
-              </a:rPr>
-              <a:t>​</a:t>
-            </a:r>
-            <a:br>
-              <a:rPr lang="en-GB" sz="2000">
-                <a:latin typeface="Source Sans Pro"/>
-                <a:ea typeface="Segoe UI"/>
-                <a:cs typeface="Segoe UI"/>
-              </a:rPr>
-            </a:br>
-            <a:r>
-              <a:rPr lang="en-GB" sz="2000" u="sng" strike="noStrike" baseline="0">
-                <a:solidFill>
-                  <a:srgbClr val="5F5F5F"/>
-                </a:solidFill>
-                <a:latin typeface="Source Sans Pro"/>
-                <a:ea typeface="Segoe UI"/>
-                <a:cs typeface="Segoe UI"/>
-                <a:hlinkClick r:id="rId4"/>
-              </a:rPr>
-              <a:t>https://www.atlassian.com/git/tutorials/comparing-workflows/gitflow-workflow</a:t>
-            </a:r>
-            <a:r>
-              <a:rPr lang="en-GB" sz="2000">
-                <a:latin typeface="Source Sans Pro"/>
-                <a:ea typeface="Segoe UI"/>
-                <a:cs typeface="Segoe UI"/>
-              </a:rPr>
-              <a:t>​</a:t>
-            </a:r>
-          </a:p>
-          <a:p>
-            <a:pPr marL="342900" lvl="0" indent="-342900" rtl="0">
-              <a:buFont typeface="Wingdings,Sans-Serif"/>
-              <a:buChar char="ü"/>
-            </a:pPr>
-            <a:endParaRPr lang="en-GB">
-              <a:latin typeface="Arial"/>
-              <a:ea typeface="Arial"/>
-              <a:cs typeface="Arial"/>
-            </a:endParaRPr>
-          </a:p>
-          <a:p>
-            <a:pPr algn="ctr"/>
-            <a:endParaRPr lang="en-GB"/>
-          </a:p>
-        </p:txBody>
-      </p:sp>
-    </p:spTree>
-    <p:extLst>
-      <p:ext uri="{BB962C8B-B14F-4D97-AF65-F5344CB8AC3E}">
-        <p14:creationId xmlns:p14="http://schemas.microsoft.com/office/powerpoint/2010/main" val="1120510944"/>
       </p:ext>
     </p:extLst>
   </p:cSld>
@@ -34822,6 +36129,35 @@
 </file>
 
 <file path=customXml/item1.xml><?xml version="1.0" encoding="utf-8"?>
+<?mso-contentType ?>
+<FormTemplates xmlns="http://schemas.microsoft.com/sharepoint/v3/contenttype/forms">
+  <Display>DocumentLibraryForm</Display>
+  <Edit>DocumentLibraryForm</Edit>
+  <New>DocumentLibraryForm</New>
+</FormTemplates>
+</file>
+
+<file path=customXml/item2.xml><?xml version="1.0" encoding="utf-8"?>
+<p:properties xmlns:p="http://schemas.microsoft.com/office/2006/metadata/properties" xmlns:xsi="http://www.w3.org/2001/XMLSchema-instance" xmlns:pc="http://schemas.microsoft.com/office/infopath/2007/PartnerControls">
+  <documentManagement>
+    <_ip_UnifiedCompliancePolicyUIAction xmlns="http://schemas.microsoft.com/sharepoint/v3" xsi:nil="true"/>
+    <Image xmlns="71af3243-3dd4-4a8d-8c0d-dd76da1f02a5">
+      <Url xsi:nil="true"/>
+      <Description xsi:nil="true"/>
+    </Image>
+    <Status xmlns="71af3243-3dd4-4a8d-8c0d-dd76da1f02a5">Not started</Status>
+    <Background xmlns="71af3243-3dd4-4a8d-8c0d-dd76da1f02a5">false</Background>
+    <_ip_UnifiedCompliancePolicyProperties xmlns="http://schemas.microsoft.com/sharepoint/v3" xsi:nil="true"/>
+    <ImageTagsTaxHTField xmlns="71af3243-3dd4-4a8d-8c0d-dd76da1f02a5">
+      <Terms xmlns="http://schemas.microsoft.com/office/infopath/2007/PartnerControls"/>
+    </ImageTagsTaxHTField>
+    <TaxCatchAll xmlns="230e9df3-be65-4c73-a93b-d1236ebd677e" xsi:nil="true"/>
+    <MediaServiceKeyPoints xmlns="71af3243-3dd4-4a8d-8c0d-dd76da1f02a5" xsi:nil="true"/>
+  </documentManagement>
+</p:properties>
+</file>
+
+<file path=customXml/item3.xml><?xml version="1.0" encoding="utf-8"?>
 <ct:contentTypeSchema xmlns:ct="http://schemas.microsoft.com/office/2006/metadata/contentType" xmlns:ma="http://schemas.microsoft.com/office/2006/metadata/properties/metaAttributes" ct:_="" ma:_="" ma:contentTypeName="Document" ma:contentTypeID="0x01010079F111ED35F8CC479449609E8A0923A6" ma:contentTypeVersion="26" ma:contentTypeDescription="Create a new document." ma:contentTypeScope="" ma:versionID="ac37c1753acd5e330d2062ccec26ea66">
   <xsd:schema xmlns:xsd="http://www.w3.org/2001/XMLSchema" xmlns:xs="http://www.w3.org/2001/XMLSchema" xmlns:p="http://schemas.microsoft.com/office/2006/metadata/properties" xmlns:ns1="http://schemas.microsoft.com/sharepoint/v3" xmlns:ns2="71af3243-3dd4-4a8d-8c0d-dd76da1f02a5" xmlns:ns3="16c05727-aa75-4e4a-9b5f-8a80a1165891" xmlns:ns4="230e9df3-be65-4c73-a93b-d1236ebd677e" targetNamespace="http://schemas.microsoft.com/office/2006/metadata/properties" ma:root="true" ma:fieldsID="3b340c7101c92c5120abd06486f94548" ns1:_="" ns2:_="" ns3:_="" ns4:_="">
     <xsd:import namespace="http://schemas.microsoft.com/sharepoint/v3"/>
@@ -35121,36 +36457,27 @@
 </ct:contentTypeSchema>
 </file>
 
-<file path=customXml/item2.xml><?xml version="1.0" encoding="utf-8"?>
-<p:properties xmlns:p="http://schemas.microsoft.com/office/2006/metadata/properties" xmlns:xsi="http://www.w3.org/2001/XMLSchema-instance" xmlns:pc="http://schemas.microsoft.com/office/infopath/2007/PartnerControls">
-  <documentManagement>
-    <_ip_UnifiedCompliancePolicyUIAction xmlns="http://schemas.microsoft.com/sharepoint/v3" xsi:nil="true"/>
-    <Image xmlns="71af3243-3dd4-4a8d-8c0d-dd76da1f02a5">
-      <Url xsi:nil="true"/>
-      <Description xsi:nil="true"/>
-    </Image>
-    <Status xmlns="71af3243-3dd4-4a8d-8c0d-dd76da1f02a5">Not started</Status>
-    <Background xmlns="71af3243-3dd4-4a8d-8c0d-dd76da1f02a5">false</Background>
-    <_ip_UnifiedCompliancePolicyProperties xmlns="http://schemas.microsoft.com/sharepoint/v3" xsi:nil="true"/>
-    <ImageTagsTaxHTField xmlns="71af3243-3dd4-4a8d-8c0d-dd76da1f02a5">
-      <Terms xmlns="http://schemas.microsoft.com/office/infopath/2007/PartnerControls"/>
-    </ImageTagsTaxHTField>
-    <TaxCatchAll xmlns="230e9df3-be65-4c73-a93b-d1236ebd677e" xsi:nil="true"/>
-    <MediaServiceKeyPoints xmlns="71af3243-3dd4-4a8d-8c0d-dd76da1f02a5" xsi:nil="true"/>
-  </documentManagement>
-</p:properties>
+<file path=customXml/itemProps1.xml><?xml version="1.0" encoding="utf-8"?>
+<ds:datastoreItem xmlns:ds="http://schemas.openxmlformats.org/officeDocument/2006/customXml" ds:itemID="{C700B919-5B9C-4D06-B24A-7BB87EEF69EA}">
+  <ds:schemaRefs>
+    <ds:schemaRef ds:uri="http://schemas.microsoft.com/sharepoint/v3/contenttype/forms"/>
+  </ds:schemaRefs>
+</ds:datastoreItem>
 </file>
 
-<file path=customXml/item3.xml><?xml version="1.0" encoding="utf-8"?>
-<?mso-contentType ?>
-<FormTemplates xmlns="http://schemas.microsoft.com/sharepoint/v3/contenttype/forms">
-  <Display>DocumentLibraryForm</Display>
-  <Edit>DocumentLibraryForm</Edit>
-  <New>DocumentLibraryForm</New>
-</FormTemplates>
+<file path=customXml/itemProps2.xml><?xml version="1.0" encoding="utf-8"?>
+<ds:datastoreItem xmlns:ds="http://schemas.openxmlformats.org/officeDocument/2006/customXml" ds:itemID="{BA7C7500-373E-4155-9EAA-9FE9576B0BE6}">
+  <ds:schemaRefs>
+    <ds:schemaRef ds:uri="http://schemas.microsoft.com/office/2006/metadata/properties"/>
+    <ds:schemaRef ds:uri="http://schemas.microsoft.com/office/infopath/2007/PartnerControls"/>
+    <ds:schemaRef ds:uri="http://schemas.microsoft.com/sharepoint/v3"/>
+    <ds:schemaRef ds:uri="71af3243-3dd4-4a8d-8c0d-dd76da1f02a5"/>
+    <ds:schemaRef ds:uri="230e9df3-be65-4c73-a93b-d1236ebd677e"/>
+  </ds:schemaRefs>
+</ds:datastoreItem>
 </file>
 
-<file path=customXml/itemProps1.xml><?xml version="1.0" encoding="utf-8"?>
+<file path=customXml/itemProps3.xml><?xml version="1.0" encoding="utf-8"?>
 <ds:datastoreItem xmlns:ds="http://schemas.openxmlformats.org/officeDocument/2006/customXml" ds:itemID="{5D948EC7-70A8-4BA0-9397-CCEC9EEE03CC}">
   <ds:schemaRefs>
     <ds:schemaRef ds:uri="http://schemas.microsoft.com/office/2006/metadata/contentType"/>
@@ -35171,26 +36498,6 @@
 </ds:datastoreItem>
 </file>
 
-<file path=customXml/itemProps2.xml><?xml version="1.0" encoding="utf-8"?>
-<ds:datastoreItem xmlns:ds="http://schemas.openxmlformats.org/officeDocument/2006/customXml" ds:itemID="{BA7C7500-373E-4155-9EAA-9FE9576B0BE6}">
-  <ds:schemaRefs>
-    <ds:schemaRef ds:uri="http://schemas.microsoft.com/office/2006/metadata/properties"/>
-    <ds:schemaRef ds:uri="http://schemas.microsoft.com/office/infopath/2007/PartnerControls"/>
-    <ds:schemaRef ds:uri="http://schemas.microsoft.com/sharepoint/v3"/>
-    <ds:schemaRef ds:uri="71af3243-3dd4-4a8d-8c0d-dd76da1f02a5"/>
-    <ds:schemaRef ds:uri="230e9df3-be65-4c73-a93b-d1236ebd677e"/>
-  </ds:schemaRefs>
-</ds:datastoreItem>
-</file>
-
-<file path=customXml/itemProps3.xml><?xml version="1.0" encoding="utf-8"?>
-<ds:datastoreItem xmlns:ds="http://schemas.openxmlformats.org/officeDocument/2006/customXml" ds:itemID="{C700B919-5B9C-4D06-B24A-7BB87EEF69EA}">
-  <ds:schemaRefs>
-    <ds:schemaRef ds:uri="http://schemas.microsoft.com/sharepoint/v3/contenttype/forms"/>
-  </ds:schemaRefs>
-</ds:datastoreItem>
-</file>
-
 <file path=docMetadata/LabelInfo.xml><?xml version="1.0" encoding="utf-8"?>
 <clbl:labelList xmlns:clbl="http://schemas.microsoft.com/office/2020/mipLabelMetadata">
   <clbl:label id="{a8019d2a-b9cd-4e22-ac21-46e49d2ef4f4}" enabled="1" method="Standard" siteId="{300571a7-dc81-432b-9ff0-75fd8ae3dde5}" removed="0"/>

</xml_diff>

<commit_message>
docs: update role title and revision date
</commit_message>
<xml_diff>
--- a/docs/REST API Workshop.pptx
+++ b/docs/REST API Workshop.pptx
@@ -13960,7 +13960,7 @@
               </a:lnSpc>
             </a:pPr>
             <a:r>
-              <a:rPr lang="en-US" b="1">
+              <a:rPr lang="en-US" b="1" dirty="0">
                 <a:solidFill>
                   <a:schemeClr val="accent5">
                     <a:lumMod val="75000"/>
@@ -13978,7 +13978,7 @@
               </a:lnSpc>
             </a:pPr>
             <a:r>
-              <a:rPr lang="en-US" b="1">
+              <a:rPr lang="en-US" b="1" dirty="0">
                 <a:solidFill>
                   <a:schemeClr val="accent5">
                     <a:lumMod val="75000"/>
@@ -13986,7 +13986,7 @@
                 </a:solidFill>
                 <a:ea typeface="Source Sans Pro"/>
               </a:rPr>
-              <a:t>26/03/2026</a:t>
+              <a:t>14/05/2026</a:t>
             </a:r>
           </a:p>
         </p:txBody>
@@ -24718,7 +24718,7 @@
           <a:p>
             <a:pPr algn="ctr"/>
             <a:r>
-              <a:rPr lang="en-GB" sz="3600" b="1">
+              <a:rPr lang="en-GB" sz="3600" b="1" dirty="0">
                 <a:solidFill>
                   <a:schemeClr val="bg2">
                     <a:lumMod val="49000"/>
@@ -24739,17 +24739,12 @@
               </a:rPr>
             </a:br>
             <a:r>
-              <a:rPr lang="en-GB" sz="3600">
-                <a:ea typeface="Source Sans Pro"/>
-              </a:rPr>
-              <a:t>Senior Software</a:t>
+              <a:rPr lang="en-US" sz="3600" dirty="0"/>
+              <a:t>Chief Technology Officer</a:t>
             </a:r>
-            <a:r>
-              <a:rPr lang="en-GB" sz="3600" dirty="0">
-                <a:ea typeface="Source Sans Pro"/>
-              </a:rPr>
-              <a:t> Engineer</a:t>
-            </a:r>
+            <a:endParaRPr lang="en-GB" sz="3600" dirty="0">
+              <a:ea typeface="Source Sans Pro"/>
+            </a:endParaRPr>
           </a:p>
           <a:p>
             <a:pPr algn="ctr"/>
@@ -24773,18 +24768,7 @@
                 </a:solidFill>
                 <a:ea typeface="Source Sans Pro"/>
               </a:rPr>
-              <a:t>7 </a:t>
-            </a:r>
-            <a:r>
-              <a:rPr lang="en-GB" sz="3600">
-                <a:solidFill>
-                  <a:schemeClr val="bg1">
-                    <a:lumMod val="76000"/>
-                  </a:schemeClr>
-                </a:solidFill>
-                <a:ea typeface="Source Sans Pro"/>
-              </a:rPr>
-              <a:t>years</a:t>
+              <a:t>Over 7 years</a:t>
             </a:r>
             <a:br>
               <a:rPr lang="en-US" sz="2000" dirty="0">
@@ -24796,17 +24780,6 @@
               </a:rPr>
             </a:br>
             <a:r>
-              <a:rPr lang="en-GB" sz="3600">
-                <a:solidFill>
-                  <a:schemeClr val="bg1">
-                    <a:lumMod val="76000"/>
-                  </a:schemeClr>
-                </a:solidFill>
-                <a:ea typeface="Source Sans Pro"/>
-              </a:rPr>
-              <a:t>Employed</a:t>
-            </a:r>
-            <a:r>
               <a:rPr lang="en-GB" sz="3600" dirty="0">
                 <a:solidFill>
                   <a:schemeClr val="bg1">
@@ -24815,7 +24788,7 @@
                 </a:solidFill>
                 <a:ea typeface="Source Sans Pro"/>
               </a:rPr>
-              <a:t> under</a:t>
+              <a:t>Employed under</a:t>
             </a:r>
             <a:br>
               <a:rPr lang="en-GB" sz="3600" dirty="0">
@@ -36129,15 +36102,6 @@
 </file>
 
 <file path=customXml/item1.xml><?xml version="1.0" encoding="utf-8"?>
-<?mso-contentType ?>
-<FormTemplates xmlns="http://schemas.microsoft.com/sharepoint/v3/contenttype/forms">
-  <Display>DocumentLibraryForm</Display>
-  <Edit>DocumentLibraryForm</Edit>
-  <New>DocumentLibraryForm</New>
-</FormTemplates>
-</file>
-
-<file path=customXml/item2.xml><?xml version="1.0" encoding="utf-8"?>
 <p:properties xmlns:p="http://schemas.microsoft.com/office/2006/metadata/properties" xmlns:xsi="http://www.w3.org/2001/XMLSchema-instance" xmlns:pc="http://schemas.microsoft.com/office/infopath/2007/PartnerControls">
   <documentManagement>
     <_ip_UnifiedCompliancePolicyUIAction xmlns="http://schemas.microsoft.com/sharepoint/v3" xsi:nil="true"/>
@@ -36155,6 +36119,15 @@
     <MediaServiceKeyPoints xmlns="71af3243-3dd4-4a8d-8c0d-dd76da1f02a5" xsi:nil="true"/>
   </documentManagement>
 </p:properties>
+</file>
+
+<file path=customXml/item2.xml><?xml version="1.0" encoding="utf-8"?>
+<?mso-contentType ?>
+<FormTemplates xmlns="http://schemas.microsoft.com/sharepoint/v3/contenttype/forms">
+  <Display>DocumentLibraryForm</Display>
+  <Edit>DocumentLibraryForm</Edit>
+  <New>DocumentLibraryForm</New>
+</FormTemplates>
 </file>
 
 <file path=customXml/item3.xml><?xml version="1.0" encoding="utf-8"?>
@@ -36458,14 +36431,6 @@
 </file>
 
 <file path=customXml/itemProps1.xml><?xml version="1.0" encoding="utf-8"?>
-<ds:datastoreItem xmlns:ds="http://schemas.openxmlformats.org/officeDocument/2006/customXml" ds:itemID="{C700B919-5B9C-4D06-B24A-7BB87EEF69EA}">
-  <ds:schemaRefs>
-    <ds:schemaRef ds:uri="http://schemas.microsoft.com/sharepoint/v3/contenttype/forms"/>
-  </ds:schemaRefs>
-</ds:datastoreItem>
-</file>
-
-<file path=customXml/itemProps2.xml><?xml version="1.0" encoding="utf-8"?>
 <ds:datastoreItem xmlns:ds="http://schemas.openxmlformats.org/officeDocument/2006/customXml" ds:itemID="{BA7C7500-373E-4155-9EAA-9FE9576B0BE6}">
   <ds:schemaRefs>
     <ds:schemaRef ds:uri="http://schemas.microsoft.com/office/2006/metadata/properties"/>
@@ -36473,6 +36438,14 @@
     <ds:schemaRef ds:uri="http://schemas.microsoft.com/sharepoint/v3"/>
     <ds:schemaRef ds:uri="71af3243-3dd4-4a8d-8c0d-dd76da1f02a5"/>
     <ds:schemaRef ds:uri="230e9df3-be65-4c73-a93b-d1236ebd677e"/>
+  </ds:schemaRefs>
+</ds:datastoreItem>
+</file>
+
+<file path=customXml/itemProps2.xml><?xml version="1.0" encoding="utf-8"?>
+<ds:datastoreItem xmlns:ds="http://schemas.openxmlformats.org/officeDocument/2006/customXml" ds:itemID="{C700B919-5B9C-4D06-B24A-7BB87EEF69EA}">
+  <ds:schemaRefs>
+    <ds:schemaRef ds:uri="http://schemas.microsoft.com/sharepoint/v3/contenttype/forms"/>
   </ds:schemaRefs>
 </ds:datastoreItem>
 </file>

</xml_diff>